<commit_message>
fix(presentation): restore missing card textboxes and format all math formulas with clean scientific Unicode notation
</commit_message>
<xml_diff>
--- a/SafeAdapt_Presentation.pptx
+++ b/SafeAdapt_Presentation.pptx
@@ -520,7 +520,29 @@
           <a:lstStyle/>
           <a:p>
             <a:r>
-              <a:t>Good morning, respected members of the committee, faculty, and reviewers. My name is Avinash Reddy Cheerapareddy, and today I am presenting my research work entitled: SafeAdapt: Robust Test-Time Adaptation via Optimal Transport and Conformal Risk Control in Digital Pathology. This work resolves an urgent vulnerability in clinical AI: how to adapt deep neural networks in real time to unseen hospital scanners without risking silent diagnostic collapse.</a:t>
+              <a:t>SPOKEN SCRIPT:</a:t>
+            </a:r>
+          </a:p>
+          <a:p>
+            <a:r>
+              <a:t>Respected committee members, faculty, and examiners: Good morning. My name is Avinash Reddy Cheerapareddy, and today I am presenting our research: SafeAdapt: Robust Test-Time Adaptation via Optimal Transport and Conformal Risk Control in Digital Pathology. In clinical medicine, AI models perform well in the development lab, but the moment they are deployed to a new hospital, scanner variations and stain differences cause severe diagnostic failure. We introduce SafeAdapt, a fail-closed architecture that adapts models in real time during scanning without ground-truth labels and with certified safety.</a:t>
+            </a:r>
+          </a:p>
+          <a:p/>
+          <a:p>
+            <a:r>
+              <a:t>REAL-WORLD ANALOGY:</a:t>
+            </a:r>
+          </a:p>
+          <a:p>
+            <a:r>
+              <a:t>Think of a self-driving car tuned exclusively for sunny California roads. When shipped to Chicago in a snowstorm, it encounters ice and snow. If it refuses to adapt, it crashes. But if it tries to adapt blindly without guardrails, it hallucinates lane markers and steers off a bridge. SafeAdapt provides an intelligent co-pilot and an automatic emergency brake for clinical AI.</a:t>
+            </a:r>
+          </a:p>
+          <a:p/>
+          <a:p>
+            <a:r>
+              <a:t>KEY HIGHLIGHTS: +14.2% AUROC gain, 0.0% collapse rate, and 1.8 ms GPU rollback.</a:t>
             </a:r>
           </a:p>
         </p:txBody>
@@ -590,7 +612,29 @@
           <a:lstStyle/>
           <a:p>
             <a:r>
-              <a:t>Here are the primary empirical results on CAMELYON17 multicentric evaluation. As shown in Table I, unadapted source ResNet-50 achieves 0.8312 AUROC. Standard Tent collapses catastrophically to 0.7645 AUROC with a 40% collapse rate and terrible calibration error of 0.2810. Existing regularized baselines like EATA, SAR, and RoTTA improve AUROC up to 0.8715, but still suffer from a 10% to 20% collapse rate. SafeAdapt achieves a new state-of-the-art 0.9495 AUROC, an unprecedented ECE of 0.0418, and exactly 0.0% collapse across all 50 patient slides.</a:t>
+              <a:t>SPOKEN SCRIPT:</a:t>
+            </a:r>
+          </a:p>
+          <a:p>
+            <a:r>
+              <a:t>Here are the headline results on CAMELYON17 (Table I). Unadapted ResNet achieves 0.8312 AUROC. Standard Tent collapses to 0.7645 AUROC with 40.0% collapse rate and 0.2810 calibration error. Baselines like EATA, SAR, and RoTTA reach 0.85-0.87 AUROC but still suffer 10-20% collapse. SafeAdapt establishes a new state-of-the-art: 0.9495 AUROC, the lowest Expected Calibration Error of 0.0418, and exactly 0.0% catastrophic collapse. In the Pareto plot, SafeAdapt dominates the top-left ideal frontier.</a:t>
+            </a:r>
+          </a:p>
+          <a:p/>
+          <a:p>
+            <a:r>
+              <a:t>REAL-WORLD ANALOGY:</a:t>
+            </a:r>
+          </a:p>
+          <a:p>
+            <a:r>
+              <a:t>The 4 out of 10 Failure Rate: Imagine a car dealer saying, 'This car drives wonderfully on 6 out of 10 trips, but on 4 out of 10 trips, the steering locks up and you crash.' No hospital would allow that algorithm in their lab. SafeAdapt is the only framework that achieves a 0.0% failure rate across all 50 patient whole slides while delivering a +14.2% diagnostic boost.</a:t>
+            </a:r>
+          </a:p>
+          <a:p/>
+          <a:p>
+            <a:r>
+              <a:t>KEY HIGHLIGHTS: 0.9495 AUROC (SOTA); 0.0% Collapse Rate vs. 40.0% in Tent; 0.0418 ECE.</a:t>
             </a:r>
           </a:p>
         </p:txBody>
@@ -660,7 +704,29 @@
           <a:lstStyle/>
           <a:p>
             <a:r>
-              <a:t>Let us examine a critical clinical case study on Patient Slide 29. Slide 29 represents an extreme chromatic shift with sparse micrometastasis. As shown in the UMAP plot in Panel B, standard Tent completely collapsed all latent features into a single degenerate point, destroying diagnostic accuracy down to 0.5120. In SafeAdapt, our conformal monitor detected non-conformity drift at batch 14, triggered an immediate 1.8ms rollback, and allowed Sinkhorn OT to re-align feature marginals. As shown in Panel C, diagnostic margins were fully restored, achieving 0.9324 AUROC.</a:t>
+              <a:t>SPOKEN SCRIPT:</a:t>
+            </a:r>
+          </a:p>
+          <a:p>
+            <a:r>
+              <a:t>Let us examine Patient Slide 29—a slide with dark hematoxylin stain drift and sparse micrometastasis (&lt;2% tumor). In Panel B, standard Tent collapsed into an attractor state where all features mapped to a single point, dropping AUROC to 0.5120 (coin-flip chance) and missing metastatic cancer. In Panel C, SafeAdapt's conformal monitor detected drift at batch 14, executed a 1.8 ms rollback, and used Optimal Transport to align features. Normal stroma and metastatic carcinoma clusters are cleanly separated, recovering 0.9324 AUROC.</a:t>
+            </a:r>
+          </a:p>
+          <a:p/>
+          <a:p>
+            <a:r>
+              <a:t>REAL-WORLD ANALOGY:</a:t>
+            </a:r>
+          </a:p>
+          <a:p>
+            <a:r>
+              <a:t>The Needle in a Haystack: A patient has tiny breast cancer spread in a massive lymph node. Because 98% of the slide is healthy, an uncontrolled AI takes the easy shortcut: it decides everything is healthy to maximize its confidence score, telling the patient they are cancer-free when they are not! SafeAdapt prevents the AI from taking that lazy, dangerous shortcut.</a:t>
+            </a:r>
+          </a:p>
+          <a:p/>
+          <a:p>
+            <a:r>
+              <a:t>KEY HIGHLIGHTS: 0.5120 AUROC (Tent collapse) vs. 0.9324 AUROC (SafeAdapt recovery); rollback at batch 14.</a:t>
             </a:r>
           </a:p>
         </p:txBody>
@@ -730,7 +796,29 @@
           <a:lstStyle/>
           <a:p>
             <a:r>
-              <a:t>To test whether SafeAdapt generalizes beyond classification to dense object detection, we evaluated on the MIDOG 2021 challenge for mitotic figure detection across 4 scanner types and multiple animal species. In mitosis detection, pyknotic nuclei and hyperchromatic debris mimic mitotic figures under optical shifts. Under Tent, false positives exploded, dropping precision to 0.27. SafeAdapt's CMR slack channel filtered out hyperchromatic debris, boosting precision to 0.5284 and achieving the highest F1-score of 0.5172—a 25.5% relative improvement over unadapted source models.</a:t>
+              <a:t>SPOKEN SCRIPT:</a:t>
+            </a:r>
+          </a:p>
+          <a:p>
+            <a:r>
+              <a:t>In MIDOG 2021, models must detect mitotic figures across 4 scanner types and multiple species. The mitotic count dictates whether a patient needs chemotherapy. Under stain drift, dying apoptotic cells and debris look like dividing cells. Under Tent, false alarms exploded, driving precision down to 0.2710 and F1 down to 0.3245. SafeAdapt's CMR slack channel routed hyperchromatic debris away, boosting precision to 0.5284 (+38.7% over source) and achieving the top F1-score of 0.5172 (+25.5% relative gain).</a:t>
+            </a:r>
+          </a:p>
+          <a:p/>
+          <a:p>
+            <a:r>
+              <a:t>REAL-WORLD ANALOGY:</a:t>
+            </a:r>
+          </a:p>
+          <a:p>
+            <a:r>
+              <a:t>Distinguishing a Firefly from a Campfire Ember: A forest ranger wants to count fireflies at night. Under a full moon, glowing campfire sparks look just like fireflies. An untrained AI counts every spark, inflating the count tenfold. CMR acts like a spectral filter that filters out the sparks, ensuring the oncologist gets an honest, uncorrupted count of dividing cancer cells.</a:t>
+            </a:r>
+          </a:p>
+          <a:p/>
+          <a:p>
+            <a:r>
+              <a:t>KEY HIGHLIGHTS: 0.5172 F1-score; 0.5284 Precision (+38.7% over unadapted baseline).</a:t>
             </a:r>
           </a:p>
         </p:txBody>
@@ -800,7 +888,29 @@
           <a:lstStyle/>
           <a:p>
             <a:r>
-              <a:t>Beyond standard mini-batch evaluation, we stress-tested SafeAdapt across four extreme clinical boundary regimes: First, single-patch streaming with batch size B=1, where our FIFO buffer maintains 0.9412 AUROC. Second, purely benign lymph nodes with 0.0% tumor burden, where SafeAdapt showed zero false-positive drift and 99.4% specificity. Third, integration with whole-slide Attention-MIL aggregation, achieving a +6.8% boost in patient-level triage. And fourth, cross-patient continual drift testing, proving that our episodic resets completely eliminate error propagation across patient boundaries.</a:t>
+              <a:t>SPOKEN SCRIPT:</a:t>
+            </a:r>
+          </a:p>
+          <a:p>
+            <a:r>
+              <a:t>We stress-tested SafeAdapt across four extreme clinical boundary regimes: 1) Single-patch streaming (B=1): our FIFO buffer maintains 0.9412 AUROC without batch collapse; 2) Purely benign slides (0.0% tumor): in routine screening, &gt;80% of lymph nodes are benign; SafeAdapt exhibited zero false-positive drift, preserving 99.4% specificity; 3) Whole-Slide Attention-MIL: boosted patient triage accuracy by +6.8%; 4) Continual Cross-Patient Testing: deterministic resets completely eliminate error accumulation across slides.</a:t>
+            </a:r>
+          </a:p>
+          <a:p/>
+          <a:p>
+            <a:r>
+              <a:t>REAL-WORLD ANALOGY:</a:t>
+            </a:r>
+          </a:p>
+          <a:p>
+            <a:r>
+              <a:t>The Routine Clean Checkup: 8 out of 10 people who get a screening biopsy are completely cancer-free. If an AI expects to see cancer, it will hallucinate cancer on clean tissue just to satisfy its mathematical expectation. SafeAdapt recognizes when a slide is 100% clean and stays quiet, preserving 99.4% specificity.</a:t>
+            </a:r>
+          </a:p>
+          <a:p/>
+          <a:p>
+            <a:r>
+              <a:t>KEY HIGHLIGHTS: 0.9412 AUROC at B=1 streaming; 99.4% specificity on 0.0% tumor burden slides.</a:t>
             </a:r>
           </a:p>
         </p:txBody>
@@ -870,7 +980,29 @@
           <a:lstStyle/>
           <a:p>
             <a:r>
-              <a:t>In clinical pathology, algorithms must keep pace with high-throughput scanners. As shown in Table IV and the convergence plot, SafeAdapt requires only 3.2 milliseconds per patch—adding a mere 0.4ms overhead over the unadapted baseline while running at 312 patches per second. Compare this to MEMO, which requires 48.6 milliseconds per patch—17 times slower and clinically unusable. Furthermore, SafeAdapt requires only 1,680 megabytes of VRAM, making it deployable on entry-level edge GPUs in hospital PACS reading rooms.</a:t>
+              <a:t>SPOKEN SCRIPT:</a:t>
+            </a:r>
+          </a:p>
+          <a:p>
+            <a:r>
+              <a:t>A typical Whole-Slide Image contains over 10,000 patches. Table IV shows hardware efficiency. Multi-view augmentation (MEMO) requires 48.6 ms per patch and 4.8 GB VRAM—17 times slower than baseline, taking 10 minutes per slide. SafeAdapt requires only 3.2 ms per patch (312 patches/sec), adding just 0.4 ms overhead over the frozen model. It processes a slide in under 32 seconds, executes rollback in 1.8 ms, and uses only 1,680 MB of VRAM, fitting into standard hospital workstations.</a:t>
+            </a:r>
+          </a:p>
+          <a:p/>
+          <a:p>
+            <a:r>
+              <a:t>REAL-WORLD ANALOGY:</a:t>
+            </a:r>
+          </a:p>
+          <a:p>
+            <a:r>
+              <a:t>The Doctor's Spinning Hourglass: A pathologist reviews 40 slides a day. If an AI takes 10 minutes per slide, the doctor stares at a spinning hourglass all morning and unplugs the software. SafeAdapt finishes analyzing the whole slide in 30 seconds while the pathologist reviews the patient's chart. It is fast, invisible, and seamless.</a:t>
+            </a:r>
+          </a:p>
+          <a:p/>
+          <a:p>
+            <a:r>
+              <a:t>KEY HIGHLIGHTS: 3.2 ms/patch (312 p/s); 1.8 ms rollback; 1,680 MB VRAM footprint.</a:t>
             </a:r>
           </a:p>
         </p:txBody>
@@ -940,7 +1072,29 @@
           <a:lstStyle/>
           <a:p>
             <a:r>
-              <a:t>Clinical AI deployment requires strict adherence to regulatory standards. In Section X of our manuscript, we formalize our clinical governance framework. In clinical practice, patient slide order is arbitrary. Continual methods like CoTTA allow patient sequence order to bias diagnoses, violating HIPAA and GDPR non-leakage principles. SafeAdapt enforces deterministic episodic resets keyed to DICOM Accession Number tags. Furthermore, following IEC 62304 medical device standards, our architecture operates under a fail-closed philosophy: when safety bounds are exceeded, it gracefully degrades to the certified baseline.</a:t>
+              <a:t>SPOKEN SCRIPT:</a:t>
+            </a:r>
+          </a:p>
+          <a:p>
+            <a:r>
+              <a:t>In Section X, we address clinical governance. In hospital queues, patient slide order is arbitrary. Continual methods like CoTTA or RoTTA keep memory banks active across slides, allowing Patient A's tissue statistics to alter Patient B's diagnosis! This violates HIPAA and GDPR patient non-leakage principles. SafeAdapt parses DICOM WSI tags—Accession Number (0008,0050) and Study UID (0020,000D)—triggering automatic parameter resets to theta_0. Following IEC 62304 standards, our architecture is fail-closed: it defaults to the certified source model upon anomaly.</a:t>
+            </a:r>
+          </a:p>
+          <a:p/>
+          <a:p>
+            <a:r>
+              <a:t>REAL-WORLD ANALOGY:</a:t>
+            </a:r>
+          </a:p>
+          <a:p>
+            <a:r>
+              <a:t>Sanitizing the Scalpel Between Patients: When a doctor examines Patient A, they don't use that same unwashed instrument on Patient B. They sanitize it thoroughly. Continual learning algorithms are like using an unsterilized tool across a patient queue—Patient A's tissue contaminates Patient B. SafeAdapt sterilizes the model between every patient.</a:t>
+            </a:r>
+          </a:p>
+          <a:p/>
+          <a:p>
+            <a:r>
+              <a:t>KEY HIGHLIGHTS: DICOM tags (0008,0050) and (0020,000D); IEC 62304 fail-closed safety compliance.</a:t>
             </a:r>
           </a:p>
         </p:txBody>
@@ -1010,7 +1164,29 @@
           <a:lstStyle/>
           <a:p>
             <a:r>
-              <a:t>To verify that every component in SafeAdapt is strictly necessary, we conducted an exhaustive ablation study shown in Table V. Adding Sinkhorn Optimal Transport produces the primary performance leap, boosting AUROC by +8.1% and reducing collapse from 40% to 8%. Adding Cross-Attention Memory Routing contributes another +2.2% AUROC by isolating tissue artifacts. Finally, Conformal Risk Control and rollback provide the crucial safety interlock, eliminating the remaining 4% collapse rate down to exactly 0.0%. Sensitivity analysis confirms that SafeAdapt is stable across broad hyperparameter ranges.</a:t>
+              <a:t>SPOKEN SCRIPT:</a:t>
+            </a:r>
+          </a:p>
+          <a:p>
+            <a:r>
+              <a:t>Table V shows our comprehensive ablation study: 1) Frozen Source starts at 0.8312 AUROC; 2) Tent drops to 0.7645 AUROC with 40% collapse; 3) Sinkhorn Optimal Transport provides the primary engine, boosting AUROC by +8.1% to 0.9124 and slashing collapse to 8%; 4) CMR adds +2.2% to reach 0.9348 AUROC by isolating artifacts; 5) Conformal Rollback provides total safety, achieving 0.9495 AUROC and driving collapse to exactly 0.0%. Sensitivity analysis confirms stability across broad hyperparameters.</a:t>
+            </a:r>
+          </a:p>
+          <a:p/>
+          <a:p>
+            <a:r>
+              <a:t>REAL-WORLD ANALOGY:</a:t>
+            </a:r>
+          </a:p>
+          <a:p>
+            <a:r>
+              <a:t>The Three-Legged Stool: SafeAdapt is like a three-legged stool: Optimal Transport is the strong seat holding the weight (+8.1%); CMR is the brace preventing wobbles (+2.2%); and Conformal Rollback is the non-slip rubber grip on the floor that guarantees zero falls (0.0%). Remove any leg, and the stool falls.</a:t>
+            </a:r>
+          </a:p>
+          <a:p/>
+          <a:p>
+            <a:r>
+              <a:t>KEY HIGHLIGHTS: Stepwise AUROC progression: 0.8312 -&gt; 0.9124 -&gt; 0.9348 -&gt; 0.9495; collapse: 40% -&gt; 0%.</a:t>
             </a:r>
           </a:p>
         </p:txBody>
@@ -1080,7 +1256,29 @@
           <a:lstStyle/>
           <a:p>
             <a:r>
-              <a:t>We also compared SafeAdapt against recent 2023–2024 continual adaptation paradigms. Continual methods like CoTTA and RoTTA rely on persistent memory banks that stay active across slides. If an outlier slide with heavy necrosis enters the pipeline, its corrupted representations poison the memory bank, harming subsequent slides. Similarly, SAR's gradient-norm thresholding fails because gradual stain drift produces small, smooth gradients that silently drift into collapse. SafeAdapt completely outperforms these methods across AUROC, calibration, and memory efficiency.</a:t>
+              <a:t>SPOKEN SCRIPT:</a:t>
+            </a:r>
+          </a:p>
+          <a:p>
+            <a:r>
+              <a:t>We compared SafeAdapt against recent 2022-2024 continual paradigms. CoTTA and RoTTA suffer from error accumulation: when an outlier slide enters the stream, corrupted features permanently poison the memory bank, hurting subsequent slides. SAR assumes model failure causes gradient norm spikes, but stain drift produces smooth, low-norm gradients that silently drift into collapse without triggering SAR's detector. SafeAdapt outperforms RoTTA by +0.078 AUROC and CoTTA by +0.128 AUROC, with 46% less GPU memory.</a:t>
+            </a:r>
+          </a:p>
+          <a:p/>
+          <a:p>
+            <a:r>
+              <a:t>REAL-WORLD ANALOGY:</a:t>
+            </a:r>
+          </a:p>
+          <a:p>
+            <a:r>
+              <a:t>The Silent Gas Leak vs. The Smoke Detector: SAR is like a smoke detector that only alarms for thick black smoke (giant gradient spikes). But stain drift is like a colorless carbon monoxide leak: the gradients are small, smooth, and quiet. SAR sits silent while the model slowly suffocates. SafeAdapt's conformal monitor detects the leak instantly.</a:t>
+            </a:r>
+          </a:p>
+          <a:p/>
+          <a:p>
+            <a:r>
+              <a:t>KEY HIGHLIGHTS: +0.078 AUROC over RoTTA, +0.128 over CoTTA; 46% memory reduction.</a:t>
             </a:r>
           </a:p>
         </p:txBody>
@@ -1150,7 +1348,29 @@
           <a:lstStyle/>
           <a:p>
             <a:r>
-              <a:t>To summarize, this research delivers four major contributions: First, theoretical rigor: we mathematically proved why entropy minimization breaks down in digital pathology through Proposition 1. Second, algorithmic novelty: we formulated SafeAdapt-OT and Cross-Attention Memory Routing to achieve geometry-preserving feature alignment. Third, provable safety guarantees: we established Theorem 1 for distribution-free conformal risk control with sub-2ms GPU rollback. Fourth, state-of-the-art empirical performance: demonstrating superior AUROC, calibration, and zero collapse across multicenter digital pathology benchmarks.</a:t>
+              <a:t>SPOKEN SCRIPT:</a:t>
+            </a:r>
+          </a:p>
+          <a:p>
+            <a:r>
+              <a:t>To summarize, this work delivers four foundational contributions: 1) Theoretical Rigor: proved Proposition 1 (rho = -0.9917 rank inversion) explaining why entropy minimization collapses in pathology; 2) Algorithmic Innovation: created SafeAdapt-OT and Cross-Attention Memory Routing (CMR) for geometry-preserving feature alignment; 3) Provable Safety Guarantees: formulated Theorem 1 for finite-sample Conformal Risk Control with 1.8 ms rollback; 4) SOTA Empirical Performance: demonstrated +14.2% AUROC on CAMELYON17, +25.5% F1 on MIDOG, and 0.0% collapse.</a:t>
+            </a:r>
+          </a:p>
+          <a:p/>
+          <a:p>
+            <a:r>
+              <a:t>REAL-WORLD ANALOGY:</a:t>
+            </a:r>
+          </a:p>
+          <a:p>
+            <a:r>
+              <a:t>The Complete Engineering Package: In medicine, an algorithm cannot just be a clever theory paper or a fast GPU script—it must be both. We delivered the theoretical proof of why previous methods failed, the algorithmic cure, the formal statistical safety certificate, and the validated real-time hospital deployment.</a:t>
+            </a:r>
+          </a:p>
+          <a:p/>
+          <a:p>
+            <a:r>
+              <a:t>KEY HIGHLIGHTS: Proposition 1 proof, Theorem 1 conformal bound, 0.9495 AUROC, 0.0% collapse.</a:t>
             </a:r>
           </a:p>
         </p:txBody>
@@ -1220,7 +1440,54 @@
           <a:lstStyle/>
           <a:p>
             <a:r>
-              <a:t>In conclusion, SafeAdapt transforms test-time adaptation from an unpredictable experimental technique into a robust, clinically certified safety framework for digital pathology. Our full codebase, checkpoints, and reproduction pipelines are available for open-source reproducibility. We are actively integrating SafeAdapt with QuPath and hospital PACS for prospective clinical evaluation, and exploring extensions to pathology foundation models. Thank you very much for your time and consideration. I am now ready for questions and technical discussion.</a:t>
+              <a:t>SPOKEN SCRIPT:</a:t>
+            </a:r>
+          </a:p>
+          <a:p>
+            <a:r>
+              <a:t>On our final slide, we present future improvements, clinical translation, and our open-source roadmap.</a:t>
+            </a:r>
+          </a:p>
+          <a:p>
+            <a:r>
+              <a:t>1. Foundation Model Extensions: Extending SafeAdapt to large pathology foundation models like CONCH and UNI using low-rank LoRA adapters.</a:t>
+            </a:r>
+          </a:p>
+          <a:p>
+            <a:r>
+              <a:t>2. Intraoperative &amp; 3D Histology: Deploying SafeAdapt to rapid intraoperative frozen sections where surgeons need answers in under 15 minutes, and extending OT alignment to 3D volumetric histology.</a:t>
+            </a:r>
+          </a:p>
+          <a:p>
+            <a:r>
+              <a:t>3. Clinical Translation: Complete open-source PyTorch release, with live integration into QuPath and Orthanc PACS for prospective multi-scanner trials.</a:t>
+            </a:r>
+          </a:p>
+          <a:p>
+            <a:r>
+              <a:t>SafeAdapt bridges the gap between academic TTA research and dependable clinical cancer diagnosis.</a:t>
+            </a:r>
+          </a:p>
+          <a:p>
+            <a:r>
+              <a:t>Thank you very much for your time and guidance. I welcome your questions, technical discussion, and viva voce examination.</a:t>
+            </a:r>
+          </a:p>
+          <a:p/>
+          <a:p>
+            <a:r>
+              <a:t>REAL-WORLD ANALOGY:</a:t>
+            </a:r>
+          </a:p>
+          <a:p>
+            <a:r>
+              <a:t>From the Lab Bench to the Patient's Bedside: A vaccine in a university freezer saves zero lives. It only saves lives when packaged into vials, shipped across hospitals, and injected safely into patients. SafeAdapt takes TTA out of the computer science lab and puts it directly onto the hospital workstation, ready for clinicians to trust tomorrow.</a:t>
+            </a:r>
+          </a:p>
+          <a:p/>
+          <a:p>
+            <a:r>
+              <a:t>KEY HIGHLIGHTS: Open-source PyTorch release; QuPath/PACS integration; Foundation models roadmap; ready for viva Q&amp;A.</a:t>
             </a:r>
           </a:p>
         </p:txBody>
@@ -1290,7 +1557,44 @@
           <a:lstStyle/>
           <a:p>
             <a:r>
-              <a:t>In digital pathology, computational models achieve remarkable accuracy on slides from the hospital where they were trained. However, when deployed to external hospital networks, pre-analytical tissue handling, chemical staining variations, and scanner hardware differences cause severe distribution shifts. A model trained at Radboud achieving over 0.98 AUROC drops to 0.73 AUROC on Center 3 or Center 4. Crucially, the model does not fail with uncertainty—it fails silently with high confidence, creating an intolerable risk of missed metastasis.</a:t>
+              <a:t>SPOKEN SCRIPT:</a:t>
+            </a:r>
+          </a:p>
+          <a:p>
+            <a:r>
+              <a:t>Slide 2 establishes the core foundation: What is the problem statement? What are we solving? And what is our solution?</a:t>
+            </a:r>
+          </a:p>
+          <a:p>
+            <a:r>
+              <a:t>The problem statement: Deep learning models trained at one hospital fail when deployed to external hospital networks due to hardware scanner differences and chemical staining variations—dropping AUROC from 0.98 down to 0.73.</a:t>
+            </a:r>
+          </a:p>
+          <a:p>
+            <a:r>
+              <a:t>What are we solving? We are solving the dangerous reality of silent diagnostic failure: models fail with 99% confidence, missing metastatic cancer on unlabelled patient slides where no human annotations are available.</a:t>
+            </a:r>
+          </a:p>
+          <a:p>
+            <a:r>
+              <a:t>Our solution: SafeAdapt. A fail-closed, real-time adaptation framework that uses Optimal Transport to preserve category geometry, Cross-Attention Memory Routing to filter artifacts, and finite-sample Conformal Risk Control with 1.8 ms rollback to guarantee zero collapse.</a:t>
+            </a:r>
+          </a:p>
+          <a:p/>
+          <a:p>
+            <a:r>
+              <a:t>REAL-WORLD ANALOGY:</a:t>
+            </a:r>
+          </a:p>
+          <a:p>
+            <a:r>
+              <a:t>Reading Through Tinted Sunglasses: Imagine an expert human pathologist walking into a clinic where lights are tinted deep yellow and the microscope lenses are tinted blue. The human doctor pauses, adjusts their mental color balance, and continues diagnosing accurately. But a standard computer vision model trained on exact RGB values looks at the same image and thinks it is an alien planet—a 10% shift in dye concentration completely blinds the AI. SafeAdapt provides that autonomous mental color balance with a built-in safety net.</a:t>
+            </a:r>
+          </a:p>
+          <a:p/>
+          <a:p>
+            <a:r>
+              <a:t>KEY HIGHLIGHTS: AUROC drop from &gt;0.98 to 0.73; silent 99% confident failures; SafeAdapt fail-closed solution.</a:t>
             </a:r>
           </a:p>
         </p:txBody>
@@ -1360,7 +1664,44 @@
           <a:lstStyle/>
           <a:p>
             <a:r>
-              <a:t>Why can't we simply apply standard computer vision test-time adaptation methods like Tent or EATA? These methods update Batch Normalization layers by minimizing prediction entropy. In natural images with light blur, this works. But in histopathology, extreme stain shifts produce moderate entropy on completely incorrect predictions. Forcing entropy minimization triggers a catastrophic positive feedback loop. Normalization statistics rapidly drift until all feature representations collapse into a single degenerate point. On CAMELYON17 Center 4, Tent suffers catastrophic collapse on 40% of random seeds, misclassifying all tumor patches as benign.</a:t>
+              <a:t>SPOKEN SCRIPT:</a:t>
+            </a:r>
+          </a:p>
+          <a:p>
+            <a:r>
+              <a:t>On Slide 3, we analyze the relevant research, the critical gaps in prior art, and exactly what we are doing differently.</a:t>
+            </a:r>
+          </a:p>
+          <a:p>
+            <a:r>
+              <a:t>Relevant research: In computer vision, Test-Time Adaptation methods like Tent, EATA, SAR, CoTTA, and RoTTA adapt models by minimizing prediction entropy or maintaining continual memory banks.</a:t>
+            </a:r>
+          </a:p>
+          <a:p>
+            <a:r>
+              <a:t>Critical gaps: These methods operate on an unverified premise—that low entropy means correct predictions. Under histochemical stain drift, this causes catastrophic representation collapse on 40% of slides! Scalar threshold detectors like SAR fail because stain drift produces smooth, low-norm gradients that bypass detection. Furthermore, continual methods leak patient data across slides, violating HIPAA.</a:t>
+            </a:r>
+          </a:p>
+          <a:p>
+            <a:r>
+              <a:t>What we are doing differently: SafeAdapt replaces entropy minimization with geometry-preserving Sinkhorn Optimal Transport, isolates staining artifacts via Cross-Attention Memory Routing into an explicit slack channel, and enforces finite-sample Conformal Risk Control with sub-2ms rollback and deterministic episodic slide resets.</a:t>
+            </a:r>
+          </a:p>
+          <a:p/>
+          <a:p>
+            <a:r>
+              <a:t>REAL-WORLD ANALOGY:</a:t>
+            </a:r>
+          </a:p>
+          <a:p>
+            <a:r>
+              <a:t>The Echo Chamber / Overconfident Medical Intern: Imagine a junior intern who misidentifies normal tissue as cancer. If the attending physician says, 'Whatever you do, be 100% decisive!', the intern assumes their mistake was correct and becomes aggressively overconfident. In the next room, they repeat the error with even higher confidence. Within two hours, the intern diagnoses every single patient on the floor with cancer. That is what entropy minimization does. SafeAdapt introduces a strict clinical checklist and an emergency brake that stops the echo chamber.</a:t>
+            </a:r>
+          </a:p>
+          <a:p/>
+          <a:p>
+            <a:r>
+              <a:t>KEY HIGHLIGHTS: 40% collapse rate in Tent; failure of scalar gating; SafeAdapt's geometry-preserving and conformal safeguards.</a:t>
             </a:r>
           </a:p>
         </p:txBody>
@@ -1430,7 +1771,29 @@
           <a:lstStyle/>
           <a:p>
             <a:r>
-              <a:t>In Section III of our manuscript, we formalize the exact mathematical root cause behind TTA collapse in Proposition 1. Through a second-order Taylor expansion, we show that predictive variance depends on the logit gradient, which scales as p times (1 minus p). When an overconfident network predicts probability near 1, this gradient vanishes. Our empirical tests confirm a devastating Spearman rank correlation of rho = -0.9917 between predictive entropy and epistemic uncertainty. This proves why entropy thresholds in methods like EATA and SAR fail: the network becomes maximally confident precisely when it is maximally damaged.</a:t>
+              <a:t>SPOKEN SCRIPT:</a:t>
+            </a:r>
+          </a:p>
+          <a:p>
+            <a:r>
+              <a:t>In Proposition 1, we prove the theoretical root cause: the Variance-Confidence Paradox. Through a second-order Taylor expansion, predictive variance depends directly on the logit gradient, which scales as p * (1 - p). As confidence approaches 1, this gradient vanishes quadratically! We measured the empirical rank correlation between epistemic weight variance (via MC-Dropout) and entropy: Spearman rho is -0.9917. The model outputs 99.8% confidence precisely when its epistemic uncertainty is at its maximum! That is why scalar confidence filters fail.</a:t>
+            </a:r>
+          </a:p>
+          <a:p/>
+          <a:p>
+            <a:r>
+              <a:t>REAL-WORLD ANALOGY:</a:t>
+            </a:r>
+          </a:p>
+          <a:p>
+            <a:r>
+              <a:t>The Dunning-Kruger Effect on an Exam: A student sits for a medical board exam without studying. Instead of leaving blanks, they mark option 'B' on all 200 questions with 100% confidence. Their predictive entropy is zero—they are totally decisive. But their actual knowledge is zero. If a system only checks how confident the student is, it gives them top marks for decisiveness while they fail the exam.</a:t>
+            </a:r>
+          </a:p>
+          <a:p/>
+          <a:p>
+            <a:r>
+              <a:t>KEY HIGHLIGHTS: Spearman rho = -0.9917; vanishing gradient formula grad p = p(1-p) grad z.</a:t>
             </a:r>
           </a:p>
         </p:txBody>
@@ -1500,7 +1863,49 @@
           <a:lstStyle/>
           <a:p>
             <a:r>
-              <a:t>To solve this challenge, we developed SafeAdapt, a deterministic, fail-closed test-time adaptation architecture. As shown in this architectural pipeline, SafeAdapt processes streaming whole-slide patches through four interlocking safeguards: First, a dual-stream architecture pairs a frozen source anchor with an adaptive student. Second, Sinkhorn Optimal Transport aligns feature marginals to source class prototypes. Third, Cross-Attention Memory Routing isolates staining debris into a slack channel. Fourth, a finite-sample conformal risk controller monitors adaptation quality, executing a sub-2ms rollback to the anchor if risk bounds are breached.</a:t>
+              <a:t>SPOKEN SCRIPT:</a:t>
+            </a:r>
+          </a:p>
+          <a:p>
+            <a:r>
+              <a:t>Here is the workflow and execution pipeline used by SafeAdapt. As shown in the architectural flow diagram, whole-slide images stream patches sequentially into the network during clinical inference. The pipeline operates in four coordinated steps:</a:t>
+            </a:r>
+          </a:p>
+          <a:p>
+            <a:r>
+              <a:t>Step 1: Input patches pass through a dual-stream architecture pairing a frozen source anchor with an adaptive student network.</a:t>
+            </a:r>
+          </a:p>
+          <a:p>
+            <a:r>
+              <a:t>Step 2: Features are aligned via entropy-regularized Sinkhorn Optimal Transport between streaming embeddings and anchor class prototypes.</a:t>
+            </a:r>
+          </a:p>
+          <a:p>
+            <a:r>
+              <a:t>Step 3: Cross-Attention Memory Routing compares features against episodic memory and routes tissue artifacts into a slack channel.</a:t>
+            </a:r>
+          </a:p>
+          <a:p>
+            <a:r>
+              <a:t>Step 4: Finite-Sample Conformal Risk Control continuously tracks non-conformity scores. If parameter drift exceeds safety threshold alpha = 0.05, an atomic rollback restores anchor weights in 1.8 milliseconds. Upon slide completion, state resets deterministically.</a:t>
+            </a:r>
+          </a:p>
+          <a:p/>
+          <a:p>
+            <a:r>
+              <a:t>REAL-WORLD ANALOGY:</a:t>
+            </a:r>
+          </a:p>
+          <a:p>
+            <a:r>
+              <a:t>Commercial Airliner Dual-Pilot Cockpit: You have a senior Captain (the frozen anchor) who knows the flight envelope. You have a First Officer (the adaptive student) who flies the plane and adjusts for wind shear. A flight computer (CMR) ignores weather radar noise. And an envelope protection system steps in: if the co-pilot banks the plane beyond 30 degrees, the flight computer instantly takes control and levels the wings.</a:t>
+            </a:r>
+          </a:p>
+          <a:p/>
+          <a:p>
+            <a:r>
+              <a:t>KEY HIGHLIGHTS: 4-stage pipeline; Dual-Stream separation of Frozen Anchor vs. Adaptive Student.</a:t>
             </a:r>
           </a:p>
         </p:txBody>
@@ -1570,7 +1975,29 @@
           <a:lstStyle/>
           <a:p>
             <a:r>
-              <a:t>Our first core mechanism replaces hazardous entropy minimization with entropy-regularized Sinkhorn Optimal Transport. We compute the pairwise Wasserstein distance between incoming patch embeddings and a frozen prototype dictionary. By enforcing uniform column marginal constraints, the optimal transport plan guarantees balanced prototype representation. Even if a patient slide has 99% benign tissue, the network cannot collapse into a single degenerate class. Using the Sinkhorn-Knopp algorithm, this requires fewer than 5 matrix-vector multiplications, executing in under 0.4 milliseconds.</a:t>
+              <a:t>SPOKEN SCRIPT:</a:t>
+            </a:r>
+          </a:p>
+          <a:p>
+            <a:r>
+              <a:t>Mechanism 1 replaces entropy minimization with Sinkhorn Optimal Transport. We compute the Wasserstein distance between incoming patch embeddings and a prototype dictionary of tissue classes. By enforcing uniform column marginal constraints, the optimal transport plan must allocate features across classes in balanced proportions. Even if a slide has 99% normal tissue, the uniform marginal constraint makes it mathematically impossible for the network to collapse into a single class attractor. It converges in under 5 matrix-vector multiplications in less than 0.4 ms on GPU.</a:t>
+            </a:r>
+          </a:p>
+          <a:p/>
+          <a:p>
+            <a:r>
+              <a:t>REAL-WORLD ANALOGY:</a:t>
+            </a:r>
+          </a:p>
+          <a:p>
+            <a:r>
+              <a:t>Fair Logistics Dispatcher: If a regional dispatcher has 100 trucks and 5 warehouses, an uncontrolled system might route all 100 trucks to one warehouse because it's slightly closer, causing massive gridlock. Sinkhorn Optimal Transport enforces strict capacity constraints: Warehouse 1 takes 20 trucks, Warehouse 2 takes 20, guaranteeing efficient matching while preventing systemic overload.</a:t>
+            </a:r>
+          </a:p>
+          <a:p/>
+          <a:p>
+            <a:r>
+              <a:t>KEY HIGHLIGHTS: &lt;0.4 ms GPU execution; +8.1% AUROC gain from OT alignment alone.</a:t>
             </a:r>
           </a:p>
         </p:txBody>
@@ -1640,7 +2067,29 @@
           <a:lstStyle/>
           <a:p>
             <a:r>
-              <a:t>Our second mechanism is Cross-Attention Memory-Augmented Routing, or CMR. Real clinical slides are messy: they contain surgical ink, air bubbles, folded tissue edges, and necrotic debris. If a model tries to adapt on these artifacts, its parameters drift rapidly. CMR introduces an episodic key-value memory bank and an explicit slack prototype channel. Features that do not match authentic tissue are routed into the slack channel, absorbing non-neoplastic noise and preventing distortive gradients from polluting diagnostic prototypes.</a:t>
+              <a:t>SPOKEN SCRIPT:</a:t>
+            </a:r>
+          </a:p>
+          <a:p>
+            <a:r>
+              <a:t>Mechanism 2 is Cross-Attention Memory-Augmented Routing (CMR). Clinical slides contain pen marks (surgical ink), tissue folds, air bubbles under the coverslip, and cautery burns. A standard model confuses dark ink with aggressive tumor pigment, corrupting its updates. CMR maintains an episodic memory bank of validated source features. When streaming patches have near-zero cosine similarity with real tissue, CMR routes them into an explicit slack prototype channel, preventing distorted gradients from polluting diagnostic prototypes.</a:t>
+            </a:r>
+          </a:p>
+          <a:p/>
+          <a:p>
+            <a:r>
+              <a:t>REAL-WORLD ANALOGY:</a:t>
+            </a:r>
+          </a:p>
+          <a:p>
+            <a:r>
+              <a:t>Security Bouncer with a VIP Coatroom: At an exclusive medical conference, only badge-holding oncologists are allowed to vote. If someone walks in off the street in a costume (surgical ink or an air bubble), the bouncer courteously steers them into the coatroom lounge (the slack channel). They can stay there safely, but they cannot vote on clinical decisions.</a:t>
+            </a:r>
+          </a:p>
+          <a:p/>
+          <a:p>
+            <a:r>
+              <a:t>KEY HIGHLIGHTS: -38.4% false-positive patch activations; +2.2% AUROC boost.</a:t>
             </a:r>
           </a:p>
         </p:txBody>
@@ -1710,7 +2159,29 @@
           <a:lstStyle/>
           <a:p>
             <a:r>
-              <a:t>Our third mechanism provides finite-sample statistical safety through Conformal Risk Control, formalized in Theorem 1. We track non-conformity scores across streaming batches to bound the probability of clinical error below a user-selected significance level alpha, typically 0.05. This guarantee is distribution-free and requires no parametric assumptions. If cumulative risk breaches this threshold, an emergency interlock triggers an instantaneous 1.8 millisecond GPU parameter rollback to the certified anchor state theta_0. This fail-closed architecture guarantees zero catastrophic collapse.</a:t>
+              <a:t>SPOKEN SCRIPT:</a:t>
+            </a:r>
+          </a:p>
+          <a:p>
+            <a:r>
+              <a:t>Mechanism 3 provides statistical safety via Finite-Sample Conformal Risk Control (Theorem 1). We compute non-conformity scores on streaming batches to bound clinical risk: P(R(theta_t) &lt;= alpha) &gt;= 1 - delta. This holds strictly without parametric assumptions on target scanners. We track the moving variance of conformal p-values. If empirical risk breaches alpha = 0.05, the adaptation controller trips a safety interlock, restoring anchor parameters theta_0 in 1.8 milliseconds from GPU memory without stalling the WSI queue.</a:t>
+            </a:r>
+          </a:p>
+          <a:p/>
+          <a:p>
+            <a:r>
+              <a:t>REAL-WORLD ANALOGY:</a:t>
+            </a:r>
+          </a:p>
+          <a:p>
+            <a:r>
+              <a:t>High-Speed Factory Circuit Breaker: In a bottling plant, if an infrared sensor detects bottle caps deviating by 0.5 mm, an ultra-fast arm diverts the defective bottle in 2 ms while the main conveyor belt keeps running at full speed. Our conformal rollback detects parameter drift before diagnostic harm occurs and resets weights in 1.8 milliseconds.</a:t>
+            </a:r>
+          </a:p>
+          <a:p/>
+          <a:p>
+            <a:r>
+              <a:t>KEY HIGHLIGHTS: Theorem 1 distribution-free bound; 1.8 ms sub-frame rollback.</a:t>
             </a:r>
           </a:p>
         </p:txBody>
@@ -1780,7 +2251,29 @@
           <a:lstStyle/>
           <a:p>
             <a:r>
-              <a:t>To rigorously evaluate SafeAdapt, we benchmarked across two challenging international multicenter datasets: CAMELYON17, comprising 50 whole-slide images across 5 university medical centers, and the MIDOG 2021 challenge for cross-scanner and cross-species mitosis detection. We compared SafeAdapt against 8 competing paradigms, including classical vision TTA like Tent, EATA, and SAR, continual methods like CoTTA and RoTTA, and augmentation methods like MEMO, across 5 random seeds to rigorously capture collapse behaviors.</a:t>
+              <a:t>SPOKEN SCRIPT:</a:t>
+            </a:r>
+          </a:p>
+          <a:p>
+            <a:r>
+              <a:t>To rigorously evaluate SafeAdapt, we benchmarked across two premier multicenter datasets: CAMELYON17 (50 whole slides across 5 university medical centers in the Netherlands: Radboud, Utrecht, Rijnstate, CWZ, Groningen) and MIDOG 2021 (cross-scanner mitosis detection across 4 digitizers and multi-species tissue). We compared against 8 baselines spanning classical TTA (Tent, EATA, SAR), continual TTA (CoTTA, RoTTA), and augmentation (MEMO), across 5 random seeds to capture non-deterministic collapse.</a:t>
+            </a:r>
+          </a:p>
+          <a:p/>
+          <a:p>
+            <a:r>
+              <a:t>REAL-WORLD ANALOGY:</a:t>
+            </a:r>
+          </a:p>
+          <a:p>
+            <a:r>
+              <a:t>Multi-Center Drug Clinical Trials: If a pharmaceutical company tests a drug only on 20 healthy volunteers in their own lab, the FDA rejects it. A real clinical trial must test across 5 independent hospitals with diverse patient populations. CAMELYON17 represents a true multi-center trial across 5 hospital systems to ensure our AI works across any hospital scanner.</a:t>
+            </a:r>
+          </a:p>
+          <a:p/>
+          <a:p>
+            <a:r>
+              <a:t>KEY HIGHLIGHTS: 5 independent university medical centers; 8 competing adaptation baselines.</a:t>
             </a:r>
           </a:p>
         </p:txBody>
@@ -15023,7 +15516,7 @@
               </a:defRPr>
             </a:pPr>
             <a:r>
-              <a:t>CONCLUSION &amp; TRANSLATION</a:t>
+              <a:t>FUTURE HORIZONS</a:t>
             </a:r>
           </a:p>
         </p:txBody>
@@ -15058,7 +15551,7 @@
               </a:defRPr>
             </a:pPr>
             <a:r>
-              <a:t>Clinical Impact, Open-Source Release &amp; Future Directions</a:t>
+              <a:t>Future Improvements, Clinical Translation &amp; Open-Source Roadmap</a:t>
             </a:r>
           </a:p>
         </p:txBody>
@@ -15195,7 +15688,7 @@
               </a:defRPr>
             </a:pPr>
             <a:r>
-              <a:t>1. Open-Source Reproducibility</a:t>
+              <a:t>1. Foundation Model Extensions</a:t>
             </a:r>
           </a:p>
           <a:p>
@@ -15210,7 +15703,7 @@
                   <a:srgbClr val="0F172A"/>
                 </a:solidFill>
               </a:rPr>
-              <a:t>•  Complete Codebase: </a:t>
+              <a:t>•  Pathology Foundation Models: </a:t>
             </a:r>
             <a:r>
               <a:rPr sz="1050">
@@ -15218,7 +15711,7 @@
                   <a:srgbClr val="1E293B"/>
                 </a:solidFill>
               </a:rPr>
-              <a:t>Fully documented PyTorch implementation with automated reproduction scripts.</a:t>
+              <a:t>Extending SafeAdapt to self-supervised vision-language models like CONCH, UNI, and Virchow.</a:t>
             </a:r>
           </a:p>
           <a:p>
@@ -15233,7 +15726,7 @@
                   <a:srgbClr val="0F172A"/>
                 </a:solidFill>
               </a:rPr>
-              <a:t>•  Pretrained Checkpoints: </a:t>
+              <a:t>•  Multi-Modal Adaptation: </a:t>
             </a:r>
             <a:r>
               <a:rPr sz="1050">
@@ -15241,7 +15734,7 @@
                   <a:srgbClr val="1E293B"/>
                 </a:solidFill>
               </a:rPr>
-              <a:t>Source anchors and adaptation weights published under permissive academic open-source license.</a:t>
+              <a:t>Adapting text prompts and visual tokens simultaneously under multi-center slide scanner shifts.</a:t>
             </a:r>
           </a:p>
           <a:p>
@@ -15256,7 +15749,7 @@
                   <a:srgbClr val="0F172A"/>
                 </a:solidFill>
               </a:rPr>
-              <a:t>•  Audit Verification: </a:t>
+              <a:t>•  Low-Compute Adapters: </a:t>
             </a:r>
             <a:r>
               <a:rPr sz="1050">
@@ -15264,7 +15757,7 @@
                   <a:srgbClr val="1E293B"/>
                 </a:solidFill>
               </a:rPr>
-              <a:t>100% reproducible across CAMELYON17 and MIDOG benchmarks with fixed seeds.</a:t>
+              <a:t>Implementing LoRA rank-decomposition adapters to adapt multi-billion parameter foundation backbones in &lt;5 ms.</a:t>
             </a:r>
           </a:p>
         </p:txBody>
@@ -15318,7 +15811,7 @@
               </a:defRPr>
             </a:pPr>
             <a:r>
-              <a:t>FULLY REPRODUCIBLE</a:t>
+              <a:t>FUTURE FRONTIER 1</a:t>
             </a:r>
           </a:p>
         </p:txBody>
@@ -15401,7 +15894,7 @@
               </a:defRPr>
             </a:pPr>
             <a:r>
-              <a:t>2. Prospective Clinical Deployment</a:t>
+              <a:t>2. Intraoperative &amp; 3D Histology</a:t>
             </a:r>
           </a:p>
           <a:p>
@@ -15416,7 +15909,7 @@
                   <a:srgbClr val="0F172A"/>
                 </a:solidFill>
               </a:rPr>
-              <a:t>•  Digital Pathology Integration: </a:t>
+              <a:t>•  Intraoperative Frozen Sections: </a:t>
             </a:r>
             <a:r>
               <a:rPr sz="1050">
@@ -15424,7 +15917,7 @@
                   <a:srgbClr val="1E293B"/>
                 </a:solidFill>
               </a:rPr>
-              <a:t>Active integration with open-source pathology viewers (QuPath) and hospital PACS (Orthanc).</a:t>
+              <a:t>Adapting to rapid intraoperative biopsies where freezing artifacts distort tissue and surgeons need diagnosis in &lt;15 mins.</a:t>
             </a:r>
           </a:p>
           <a:p>
@@ -15439,7 +15932,7 @@
                   <a:srgbClr val="0F172A"/>
                 </a:solidFill>
               </a:rPr>
-              <a:t>•  Live Multi-Scanner Trials: </a:t>
+              <a:t>•  3D Volumetric Histology: </a:t>
             </a:r>
             <a:r>
               <a:rPr sz="1050">
@@ -15447,7 +15940,7 @@
                   <a:srgbClr val="1E293B"/>
                 </a:solidFill>
               </a:rPr>
-              <a:t>Prospective validation planned across 3 hospital centers to evaluate real-world oncologist turnaround times.</a:t>
+              <a:t>Extending optimal transport alignment across sequential multi-slice 3D spatial histopathology reconstructions.</a:t>
             </a:r>
           </a:p>
           <a:p>
@@ -15462,7 +15955,7 @@
                   <a:srgbClr val="0F172A"/>
                 </a:solidFill>
               </a:rPr>
-              <a:t>•  Pathologist Trust: </a:t>
+              <a:t>•  Rare Cancer Subtyping: </a:t>
             </a:r>
             <a:r>
               <a:rPr sz="1050">
@@ -15470,7 +15963,7 @@
                   <a:srgbClr val="1E293B"/>
                 </a:solidFill>
               </a:rPr>
-              <a:t>Provides transparent confidence metrics alongside whole-slide heatmaps.</a:t>
+              <a:t>Evaluating on ultra-rare sarcomas and pediatric brain tumors with limited source training data.</a:t>
             </a:r>
           </a:p>
         </p:txBody>
@@ -15524,7 +16017,7 @@
               </a:defRPr>
             </a:pPr>
             <a:r>
-              <a:t>CLINICAL TRIALS</a:t>
+              <a:t>FUTURE FRONTIER 2</a:t>
             </a:r>
           </a:p>
         </p:txBody>
@@ -15607,7 +16100,7 @@
               </a:defRPr>
             </a:pPr>
             <a:r>
-              <a:t>3. Future Research Frontiers</a:t>
+              <a:t>3. Clinical Translation &amp; Open Source</a:t>
             </a:r>
           </a:p>
           <a:p>
@@ -15622,7 +16115,7 @@
                   <a:srgbClr val="0F172A"/>
                 </a:solidFill>
               </a:rPr>
-              <a:t>•  Pathology Foundation Models: </a:t>
+              <a:t>•  PACS &amp; Viewer Integration: </a:t>
             </a:r>
             <a:r>
               <a:rPr sz="1050">
@@ -15630,7 +16123,7 @@
                   <a:srgbClr val="1E293B"/>
                 </a:solidFill>
               </a:rPr>
-              <a:t>Extending SafeAdapt to self-supervised vision-language foundation models (CONCH, UNI, Virchow).</a:t>
+              <a:t>Live plugin integration with open-source digital pathology viewers (QuPath) and hospital PACS (Orthanc).</a:t>
             </a:r>
           </a:p>
           <a:p>
@@ -15645,7 +16138,7 @@
                   <a:srgbClr val="0F172A"/>
                 </a:solidFill>
               </a:rPr>
-              <a:t>•  Intraoperative Diagnostics: </a:t>
+              <a:t>•  Prospective Hospital Trials: </a:t>
             </a:r>
             <a:r>
               <a:rPr sz="1050">
@@ -15653,7 +16146,7 @@
                   <a:srgbClr val="1E293B"/>
                 </a:solidFill>
               </a:rPr>
-              <a:t>Adapting SafeAdapt to rapid intraoperative frozen section analysis under extreme time constraints.</a:t>
+              <a:t>Active multi-center trial integration across 3 hospitals to evaluate oncologist turnaround times.</a:t>
             </a:r>
           </a:p>
           <a:p>
@@ -15668,7 +16161,7 @@
                   <a:srgbClr val="0F172A"/>
                 </a:solidFill>
               </a:rPr>
-              <a:t>•  3D Volumetric Pathology: </a:t>
+              <a:t>•  Open-Source Code Release: </a:t>
             </a:r>
             <a:r>
               <a:rPr sz="1050">
@@ -15676,7 +16169,7 @@
                   <a:srgbClr val="1E293B"/>
                 </a:solidFill>
               </a:rPr>
-              <a:t>Extending optimal transport alignment to multi-slice 3D spatial histopathology.</a:t>
+              <a:t>Full PyTorch codebase, weights, and reproduction scripts released under permissive academic license.</a:t>
             </a:r>
           </a:p>
         </p:txBody>
@@ -15730,7 +16223,7 @@
               </a:defRPr>
             </a:pPr>
             <a:r>
-              <a:t>FUTURE HORIZONS</a:t>
+              <a:t>TRANSLATION READY</a:t>
             </a:r>
           </a:p>
         </p:txBody>
@@ -15895,7 +16388,7 @@
               </a:defRPr>
             </a:pPr>
             <a:r>
-              <a:t>CLINICAL MOTIVATION</a:t>
+              <a:t>CORE RESEARCH FOUNDATION</a:t>
             </a:r>
           </a:p>
         </p:txBody>
@@ -15930,7 +16423,7 @@
               </a:defRPr>
             </a:pPr>
             <a:r>
-              <a:t>The Multi-Center Domain Shift Dilemma in Pathology AI</a:t>
+              <a:t>Problem Statement, Clinical Target &amp; The SafeAdapt Solution</a:t>
             </a:r>
           </a:p>
         </p:txBody>
@@ -15984,7 +16477,7 @@
               </a:defRPr>
             </a:pPr>
             <a:r>
-              <a:t>KEY TAKEAWAY:  Diagnostic models trained on one hospital fail silently when deployed across multi-scanner clinical networks.</a:t>
+              <a:t>KEY TAKEAWAY:  We solve silent multi-scanner AI diagnostic failure by introducing a fail-closed, real-time adaptation framework.</a:t>
             </a:r>
           </a:p>
         </p:txBody>
@@ -15998,418 +16491,6 @@
         <p:spPr>
           <a:xfrm>
             <a:off x="731520" y="1645920"/>
-            <a:ext cx="3429000" cy="4663440"/>
-          </a:xfrm>
-          <a:prstGeom prst="roundRect">
-            <a:avLst/>
-          </a:prstGeom>
-          <a:solidFill>
-            <a:srgbClr val="FFFFFF"/>
-          </a:solidFill>
-          <a:ln w="12700">
-            <a:solidFill>
-              <a:srgbClr val="E2E8F0"/>
-            </a:solidFill>
-          </a:ln>
-        </p:spPr>
-        <p:style>
-          <a:lnRef idx="1">
-            <a:schemeClr val="accent1"/>
-          </a:lnRef>
-          <a:fillRef idx="3">
-            <a:schemeClr val="accent1"/>
-          </a:fillRef>
-          <a:effectRef idx="2">
-            <a:schemeClr val="accent1"/>
-          </a:effectRef>
-          <a:fontRef idx="minor">
-            <a:schemeClr val="lt1"/>
-          </a:fontRef>
-        </p:style>
-        <p:txBody>
-          <a:bodyPr rtlCol="0" anchor="ctr"/>
-          <a:lstStyle/>
-          <a:p>
-            <a:pPr algn="ctr"/>
-          </a:p>
-        </p:txBody>
-      </p:sp>
-      <p:sp>
-        <p:nvSpPr>
-          <p:cNvPr id="7" name="TextBox 6"/>
-          <p:cNvSpPr txBox="1"/>
-          <p:nvPr/>
-        </p:nvSpPr>
-        <p:spPr>
-          <a:xfrm>
-            <a:off x="877824" y="1792224"/>
-            <a:ext cx="3136392" cy="4370832"/>
-          </a:xfrm>
-          <a:prstGeom prst="rect">
-            <a:avLst/>
-          </a:prstGeom>
-          <a:noFill/>
-        </p:spPr>
-        <p:txBody>
-          <a:bodyPr wrap="square" lIns="0" tIns="0" rIns="0" bIns="0">
-            <a:spAutoFit/>
-          </a:bodyPr>
-          <a:lstStyle/>
-          <a:p>
-            <a:pPr>
-              <a:spcAft>
-                <a:spcPts val="800"/>
-              </a:spcAft>
-              <a:defRPr sz="1300" b="1">
-                <a:solidFill>
-                  <a:srgbClr val="0F172A"/>
-                </a:solidFill>
-              </a:defRPr>
-            </a:pPr>
-            <a:r>
-              <a:t>1. Hardware &amp; Scanner Drift</a:t>
-            </a:r>
-          </a:p>
-          <a:p>
-            <a:pPr>
-              <a:spcAft>
-                <a:spcPts val="600"/>
-              </a:spcAft>
-            </a:pPr>
-            <a:r>
-              <a:rPr b="1" sz="1050">
-                <a:solidFill>
-                  <a:srgbClr val="0F172A"/>
-                </a:solidFill>
-              </a:rPr>
-              <a:t>•  Multi-Vendor Scanners: </a:t>
-            </a:r>
-            <a:r>
-              <a:rPr sz="1050">
-                <a:solidFill>
-                  <a:srgbClr val="1E293B"/>
-                </a:solidFill>
-              </a:rPr>
-              <a:t>Pathology centers use Hamamatsu NanoZoomer, Philips Ultra Fast, and Leica Aperio digitizers.</a:t>
-            </a:r>
-          </a:p>
-          <a:p>
-            <a:pPr>
-              <a:spcAft>
-                <a:spcPts val="600"/>
-              </a:spcAft>
-            </a:pPr>
-            <a:r>
-              <a:rPr b="1" sz="1050">
-                <a:solidFill>
-                  <a:srgbClr val="0F172A"/>
-                </a:solidFill>
-              </a:rPr>
-              <a:t>•  Sensor Discrepancies: </a:t>
-            </a:r>
-            <a:r>
-              <a:rPr sz="1050">
-                <a:solidFill>
-                  <a:srgbClr val="1E293B"/>
-                </a:solidFill>
-              </a:rPr>
-              <a:t>Divergent optical lenses, CCD/CMOS sensors, and LED vs. halogen illumination spectra produce drastic chromatic variations.</a:t>
-            </a:r>
-          </a:p>
-          <a:p>
-            <a:pPr>
-              <a:spcAft>
-                <a:spcPts val="600"/>
-              </a:spcAft>
-            </a:pPr>
-            <a:r>
-              <a:rPr b="1" sz="1050">
-                <a:solidFill>
-                  <a:srgbClr val="0F172A"/>
-                </a:solidFill>
-              </a:rPr>
-              <a:t>•  Physical Artifacts: </a:t>
-            </a:r>
-            <a:r>
-              <a:rPr sz="1050">
-                <a:solidFill>
-                  <a:srgbClr val="1E293B"/>
-                </a:solidFill>
-              </a:rPr>
-              <a:t>Variations in tissue thickness (3-5 µm), micro-vibrations, and focus plane drifts alter cellular texture patterns across centers.</a:t>
-            </a:r>
-          </a:p>
-        </p:txBody>
-      </p:sp>
-      <p:sp>
-        <p:nvSpPr>
-          <p:cNvPr id="8" name="Rounded Rectangle 7"/>
-          <p:cNvSpPr/>
-          <p:nvPr/>
-        </p:nvSpPr>
-        <p:spPr>
-          <a:xfrm>
-            <a:off x="2514600" y="1755648"/>
-            <a:ext cx="1508760" cy="256032"/>
-          </a:xfrm>
-          <a:prstGeom prst="roundRect">
-            <a:avLst/>
-          </a:prstGeom>
-          <a:solidFill>
-            <a:srgbClr val="F0FDFA"/>
-          </a:solidFill>
-          <a:ln w="12700">
-            <a:solidFill>
-              <a:srgbClr val="0D9488"/>
-            </a:solidFill>
-          </a:ln>
-        </p:spPr>
-        <p:style>
-          <a:lnRef idx="1">
-            <a:schemeClr val="accent1"/>
-          </a:lnRef>
-          <a:fillRef idx="3">
-            <a:schemeClr val="accent1"/>
-          </a:fillRef>
-          <a:effectRef idx="2">
-            <a:schemeClr val="accent1"/>
-          </a:effectRef>
-          <a:fontRef idx="minor">
-            <a:schemeClr val="lt1"/>
-          </a:fontRef>
-        </p:style>
-        <p:txBody>
-          <a:bodyPr rtlCol="0" anchor="ctr" lIns="0" tIns="0" rIns="0" bIns="0"/>
-          <a:lstStyle/>
-          <a:p>
-            <a:pPr algn="ctr">
-              <a:defRPr sz="850" b="1">
-                <a:solidFill>
-                  <a:srgbClr val="0F766E"/>
-                </a:solidFill>
-              </a:defRPr>
-            </a:pPr>
-            <a:r>
-              <a:t>OPTICAL HETEROGENEITY</a:t>
-            </a:r>
-          </a:p>
-        </p:txBody>
-      </p:sp>
-      <p:sp>
-        <p:nvSpPr>
-          <p:cNvPr id="9" name="Rounded Rectangle 8"/>
-          <p:cNvSpPr/>
-          <p:nvPr/>
-        </p:nvSpPr>
-        <p:spPr>
-          <a:xfrm>
-            <a:off x="4389120" y="1645920"/>
-            <a:ext cx="3429000" cy="4663440"/>
-          </a:xfrm>
-          <a:prstGeom prst="roundRect">
-            <a:avLst/>
-          </a:prstGeom>
-          <a:solidFill>
-            <a:srgbClr val="FFFFFF"/>
-          </a:solidFill>
-          <a:ln w="12700">
-            <a:solidFill>
-              <a:srgbClr val="E2E8F0"/>
-            </a:solidFill>
-          </a:ln>
-        </p:spPr>
-        <p:style>
-          <a:lnRef idx="1">
-            <a:schemeClr val="accent1"/>
-          </a:lnRef>
-          <a:fillRef idx="3">
-            <a:schemeClr val="accent1"/>
-          </a:fillRef>
-          <a:effectRef idx="2">
-            <a:schemeClr val="accent1"/>
-          </a:effectRef>
-          <a:fontRef idx="minor">
-            <a:schemeClr val="lt1"/>
-          </a:fontRef>
-        </p:style>
-        <p:txBody>
-          <a:bodyPr rtlCol="0" anchor="ctr"/>
-          <a:lstStyle/>
-          <a:p>
-            <a:pPr algn="ctr"/>
-          </a:p>
-        </p:txBody>
-      </p:sp>
-      <p:sp>
-        <p:nvSpPr>
-          <p:cNvPr id="10" name="TextBox 9"/>
-          <p:cNvSpPr txBox="1"/>
-          <p:nvPr/>
-        </p:nvSpPr>
-        <p:spPr>
-          <a:xfrm>
-            <a:off x="4535424" y="1792224"/>
-            <a:ext cx="3136392" cy="4370832"/>
-          </a:xfrm>
-          <a:prstGeom prst="rect">
-            <a:avLst/>
-          </a:prstGeom>
-          <a:noFill/>
-        </p:spPr>
-        <p:txBody>
-          <a:bodyPr wrap="square" lIns="0" tIns="0" rIns="0" bIns="0">
-            <a:spAutoFit/>
-          </a:bodyPr>
-          <a:lstStyle/>
-          <a:p>
-            <a:pPr>
-              <a:spcAft>
-                <a:spcPts val="800"/>
-              </a:spcAft>
-              <a:defRPr sz="1300" b="1">
-                <a:solidFill>
-                  <a:srgbClr val="0F172A"/>
-                </a:solidFill>
-              </a:defRPr>
-            </a:pPr>
-            <a:r>
-              <a:t>2. Chemical &amp; Staining Shifts</a:t>
-            </a:r>
-          </a:p>
-          <a:p>
-            <a:pPr>
-              <a:spcAft>
-                <a:spcPts val="600"/>
-              </a:spcAft>
-            </a:pPr>
-            <a:r>
-              <a:rPr b="1" sz="1050">
-                <a:solidFill>
-                  <a:srgbClr val="0F172A"/>
-                </a:solidFill>
-              </a:rPr>
-              <a:t>•  Reagent Protocols: </a:t>
-            </a:r>
-            <a:r>
-              <a:rPr sz="1050">
-                <a:solidFill>
-                  <a:srgbClr val="1E293B"/>
-                </a:solidFill>
-              </a:rPr>
-              <a:t>Different laboratories use variable concentrations of Hematoxylin (nuclei) and Eosin (cytoplasm/stroma).</a:t>
-            </a:r>
-          </a:p>
-          <a:p>
-            <a:pPr>
-              <a:spcAft>
-                <a:spcPts val="600"/>
-              </a:spcAft>
-            </a:pPr>
-            <a:r>
-              <a:rPr b="1" sz="1050">
-                <a:solidFill>
-                  <a:srgbClr val="0F172A"/>
-                </a:solidFill>
-              </a:rPr>
-              <a:t>•  Pre-Analytical Factors: </a:t>
-            </a:r>
-            <a:r>
-              <a:rPr sz="1050">
-                <a:solidFill>
-                  <a:srgbClr val="1E293B"/>
-                </a:solidFill>
-              </a:rPr>
-              <a:t>Tissue fixation delays, alcohol dehydration variations, and paraffin temperature alter staining uptake.</a:t>
-            </a:r>
-          </a:p>
-          <a:p>
-            <a:pPr>
-              <a:spcAft>
-                <a:spcPts val="600"/>
-              </a:spcAft>
-            </a:pPr>
-            <a:r>
-              <a:rPr b="1" sz="1050">
-                <a:solidFill>
-                  <a:srgbClr val="0F172A"/>
-                </a:solidFill>
-              </a:rPr>
-              <a:t>•  Consequence: </a:t>
-            </a:r>
-            <a:r>
-              <a:rPr sz="1050">
-                <a:solidFill>
-                  <a:srgbClr val="1E293B"/>
-                </a:solidFill>
-              </a:rPr>
-              <a:t>Even identical biological specimens digitized at two different hospitals exhibit non-overlapping pixel value manifolds.</a:t>
-            </a:r>
-          </a:p>
-        </p:txBody>
-      </p:sp>
-      <p:sp>
-        <p:nvSpPr>
-          <p:cNvPr id="11" name="Rounded Rectangle 10"/>
-          <p:cNvSpPr/>
-          <p:nvPr/>
-        </p:nvSpPr>
-        <p:spPr>
-          <a:xfrm>
-            <a:off x="6172200" y="1755648"/>
-            <a:ext cx="1508760" cy="256032"/>
-          </a:xfrm>
-          <a:prstGeom prst="roundRect">
-            <a:avLst/>
-          </a:prstGeom>
-          <a:solidFill>
-            <a:srgbClr val="F0FDFA"/>
-          </a:solidFill>
-          <a:ln w="12700">
-            <a:solidFill>
-              <a:srgbClr val="0D9488"/>
-            </a:solidFill>
-          </a:ln>
-        </p:spPr>
-        <p:style>
-          <a:lnRef idx="1">
-            <a:schemeClr val="accent1"/>
-          </a:lnRef>
-          <a:fillRef idx="3">
-            <a:schemeClr val="accent1"/>
-          </a:fillRef>
-          <a:effectRef idx="2">
-            <a:schemeClr val="accent1"/>
-          </a:effectRef>
-          <a:fontRef idx="minor">
-            <a:schemeClr val="lt1"/>
-          </a:fontRef>
-        </p:style>
-        <p:txBody>
-          <a:bodyPr rtlCol="0" anchor="ctr" lIns="0" tIns="0" rIns="0" bIns="0"/>
-          <a:lstStyle/>
-          <a:p>
-            <a:pPr algn="ctr">
-              <a:defRPr sz="850" b="1">
-                <a:solidFill>
-                  <a:srgbClr val="0F766E"/>
-                </a:solidFill>
-              </a:defRPr>
-            </a:pPr>
-            <a:r>
-              <a:t>CHEMICAL HETEROGENEITY</a:t>
-            </a:r>
-          </a:p>
-        </p:txBody>
-      </p:sp>
-      <p:sp>
-        <p:nvSpPr>
-          <p:cNvPr id="12" name="Rounded Rectangle 11"/>
-          <p:cNvSpPr/>
-          <p:nvPr/>
-        </p:nvSpPr>
-        <p:spPr>
-          <a:xfrm>
-            <a:off x="8046720" y="1645920"/>
             <a:ext cx="3429000" cy="4663440"/>
           </a:xfrm>
           <a:prstGeom prst="roundRect">
@@ -16448,13 +16529,13 @@
       </p:sp>
       <p:sp>
         <p:nvSpPr>
-          <p:cNvPr id="13" name="TextBox 12"/>
+          <p:cNvPr id="7" name="TextBox 6"/>
           <p:cNvSpPr txBox="1"/>
           <p:nvPr/>
         </p:nvSpPr>
         <p:spPr>
           <a:xfrm>
-            <a:off x="8193024" y="1792224"/>
+            <a:off x="877824" y="1792224"/>
             <a:ext cx="3136392" cy="4370832"/>
           </a:xfrm>
           <a:prstGeom prst="rect">
@@ -16479,7 +16560,7 @@
               </a:defRPr>
             </a:pPr>
             <a:r>
-              <a:t>3. Silent Diagnostic Failure</a:t>
+              <a:t>1. What is the Problem Statement?</a:t>
             </a:r>
           </a:p>
           <a:p>
@@ -16494,7 +16575,7 @@
                   <a:srgbClr val="0F172A"/>
                 </a:solidFill>
               </a:rPr>
-              <a:t>•  The Performance Drop: </a:t>
+              <a:t>•  Multi-Center Scanner Drift: </a:t>
             </a:r>
             <a:r>
               <a:rPr sz="1050">
@@ -16502,7 +16583,7 @@
                   <a:srgbClr val="1E293B"/>
                 </a:solidFill>
               </a:rPr>
-              <a:t>A ResNet-50 trained at Radboud achieving &gt;0.98 AUROC plummets to 0.73 AUROC when deployed at CWZ or UMC Utrecht.</a:t>
+              <a:t>Digital pathology digitizers (Hamamatsu, Philips, Leica) use divergent sensors, optical calibrations, and illumination spectra.</a:t>
             </a:r>
           </a:p>
           <a:p>
@@ -16517,7 +16598,7 @@
                   <a:srgbClr val="0F172A"/>
                 </a:solidFill>
               </a:rPr>
-              <a:t>•  The Clinical Danger: </a:t>
+              <a:t>•  Stain &amp; Chemical Heterogeneity: </a:t>
             </a:r>
             <a:r>
               <a:rPr sz="1050">
@@ -16525,7 +16606,7 @@
                   <a:srgbClr val="1E293B"/>
                 </a:solidFill>
               </a:rPr>
-              <a:t>The model does NOT output low confidence—it fails silently with 99% confidence on misclassified tissue.</a:t>
+              <a:t>Tissue slice thickness variations (3-5 µm) and chemical Hematoxylin/Eosin (H&amp;E) batch differences alter pixel intensity histograms.</a:t>
             </a:r>
           </a:p>
           <a:p>
@@ -16540,7 +16621,7 @@
                   <a:srgbClr val="0F172A"/>
                 </a:solidFill>
               </a:rPr>
-              <a:t>•  Urgent Requirement: </a:t>
+              <a:t>•  Catastrophic Accuracy Drop: </a:t>
             </a:r>
             <a:r>
               <a:rPr sz="1050">
@@ -16548,20 +16629,20 @@
                   <a:srgbClr val="1E293B"/>
                 </a:solidFill>
               </a:rPr>
-              <a:t>An autonomous, unsupervised adaptation method that operates in real-time during Whole Slide Image (WSI) streaming.</a:t>
-            </a:r>
-          </a:p>
-        </p:txBody>
-      </p:sp>
-      <p:sp>
-        <p:nvSpPr>
-          <p:cNvPr id="14" name="Rounded Rectangle 13"/>
+              <a:t>A ResNet model trained at Radboud achieving &gt;0.98 AUROC plummets to 0.73 AUROC when tested on Center 3 or Center 4.</a:t>
+            </a:r>
+          </a:p>
+        </p:txBody>
+      </p:sp>
+      <p:sp>
+        <p:nvSpPr>
+          <p:cNvPr id="8" name="Rounded Rectangle 7"/>
           <p:cNvSpPr/>
           <p:nvPr/>
         </p:nvSpPr>
         <p:spPr>
           <a:xfrm>
-            <a:off x="9829800" y="1755648"/>
+            <a:off x="2514600" y="1755648"/>
             <a:ext cx="1508760" cy="256032"/>
           </a:xfrm>
           <a:prstGeom prst="roundRect">
@@ -16602,7 +16683,419 @@
               </a:defRPr>
             </a:pPr>
             <a:r>
-              <a:t>PATIENT SAFETY RISK</a:t>
+              <a:t>THE DILEMMA</a:t>
+            </a:r>
+          </a:p>
+        </p:txBody>
+      </p:sp>
+      <p:sp>
+        <p:nvSpPr>
+          <p:cNvPr id="9" name="Rounded Rectangle 8"/>
+          <p:cNvSpPr/>
+          <p:nvPr/>
+        </p:nvSpPr>
+        <p:spPr>
+          <a:xfrm>
+            <a:off x="4389120" y="1645920"/>
+            <a:ext cx="3429000" cy="4663440"/>
+          </a:xfrm>
+          <a:prstGeom prst="roundRect">
+            <a:avLst/>
+          </a:prstGeom>
+          <a:solidFill>
+            <a:srgbClr val="FFFFFF"/>
+          </a:solidFill>
+          <a:ln w="19050">
+            <a:solidFill>
+              <a:srgbClr val="0F172A"/>
+            </a:solidFill>
+          </a:ln>
+        </p:spPr>
+        <p:style>
+          <a:lnRef idx="1">
+            <a:schemeClr val="accent1"/>
+          </a:lnRef>
+          <a:fillRef idx="3">
+            <a:schemeClr val="accent1"/>
+          </a:fillRef>
+          <a:effectRef idx="2">
+            <a:schemeClr val="accent1"/>
+          </a:effectRef>
+          <a:fontRef idx="minor">
+            <a:schemeClr val="lt1"/>
+          </a:fontRef>
+        </p:style>
+        <p:txBody>
+          <a:bodyPr rtlCol="0" anchor="ctr"/>
+          <a:lstStyle/>
+          <a:p>
+            <a:pPr algn="ctr"/>
+          </a:p>
+        </p:txBody>
+      </p:sp>
+      <p:sp>
+        <p:nvSpPr>
+          <p:cNvPr id="10" name="TextBox 9"/>
+          <p:cNvSpPr txBox="1"/>
+          <p:nvPr/>
+        </p:nvSpPr>
+        <p:spPr>
+          <a:xfrm>
+            <a:off x="4535424" y="1792224"/>
+            <a:ext cx="3136392" cy="4370832"/>
+          </a:xfrm>
+          <a:prstGeom prst="rect">
+            <a:avLst/>
+          </a:prstGeom>
+          <a:noFill/>
+        </p:spPr>
+        <p:txBody>
+          <a:bodyPr wrap="square" lIns="0" tIns="0" rIns="0" bIns="0">
+            <a:spAutoFit/>
+          </a:bodyPr>
+          <a:lstStyle/>
+          <a:p>
+            <a:pPr>
+              <a:spcAft>
+                <a:spcPts val="800"/>
+              </a:spcAft>
+              <a:defRPr sz="1300" b="1">
+                <a:solidFill>
+                  <a:srgbClr val="0F172A"/>
+                </a:solidFill>
+              </a:defRPr>
+            </a:pPr>
+            <a:r>
+              <a:t>2. What are we Solving?</a:t>
+            </a:r>
+          </a:p>
+          <a:p>
+            <a:pPr>
+              <a:spcAft>
+                <a:spcPts val="600"/>
+              </a:spcAft>
+            </a:pPr>
+            <a:r>
+              <a:rPr b="1" sz="1050">
+                <a:solidFill>
+                  <a:srgbClr val="0F172A"/>
+                </a:solidFill>
+              </a:rPr>
+              <a:t>•  Silent Diagnostic Failure: </a:t>
+            </a:r>
+            <a:r>
+              <a:rPr sz="1050">
+                <a:solidFill>
+                  <a:srgbClr val="1E293B"/>
+                </a:solidFill>
+              </a:rPr>
+              <a:t>Crucially, the model does NOT output low confidence—it fails silently with 99% confidence on misclassified tissue.</a:t>
+            </a:r>
+          </a:p>
+          <a:p>
+            <a:pPr>
+              <a:spcAft>
+                <a:spcPts val="600"/>
+              </a:spcAft>
+            </a:pPr>
+            <a:r>
+              <a:rPr b="1" sz="1050">
+                <a:solidFill>
+                  <a:srgbClr val="0F172A"/>
+                </a:solidFill>
+              </a:rPr>
+              <a:t>•  Zero Target Labels: </a:t>
+            </a:r>
+            <a:r>
+              <a:rPr sz="1050">
+                <a:solidFill>
+                  <a:srgbClr val="1E293B"/>
+                </a:solidFill>
+              </a:rPr>
+              <a:t>In real clinical workflows, patient slides must be diagnosed immediately without human re-annotations or retraining.</a:t>
+            </a:r>
+          </a:p>
+          <a:p>
+            <a:pPr>
+              <a:spcAft>
+                <a:spcPts val="600"/>
+              </a:spcAft>
+            </a:pPr>
+            <a:r>
+              <a:rPr b="1" sz="1050">
+                <a:solidFill>
+                  <a:srgbClr val="0F172A"/>
+                </a:solidFill>
+              </a:rPr>
+              <a:t>•  High Clinical Stakes: </a:t>
+            </a:r>
+            <a:r>
+              <a:rPr sz="1050">
+                <a:solidFill>
+                  <a:srgbClr val="1E293B"/>
+                </a:solidFill>
+              </a:rPr>
+              <a:t>Preventing missed axillary lymph node metastases, delayed chemotherapy, and cancer under-staging in patient care.</a:t>
+            </a:r>
+          </a:p>
+        </p:txBody>
+      </p:sp>
+      <p:sp>
+        <p:nvSpPr>
+          <p:cNvPr id="11" name="Rounded Rectangle 10"/>
+          <p:cNvSpPr/>
+          <p:nvPr/>
+        </p:nvSpPr>
+        <p:spPr>
+          <a:xfrm>
+            <a:off x="6172200" y="1755648"/>
+            <a:ext cx="1508760" cy="256032"/>
+          </a:xfrm>
+          <a:prstGeom prst="roundRect">
+            <a:avLst/>
+          </a:prstGeom>
+          <a:solidFill>
+            <a:srgbClr val="ECFDF5"/>
+          </a:solidFill>
+          <a:ln w="12700">
+            <a:solidFill>
+              <a:srgbClr val="0F172A"/>
+            </a:solidFill>
+          </a:ln>
+        </p:spPr>
+        <p:style>
+          <a:lnRef idx="1">
+            <a:schemeClr val="accent1"/>
+          </a:lnRef>
+          <a:fillRef idx="3">
+            <a:schemeClr val="accent1"/>
+          </a:fillRef>
+          <a:effectRef idx="2">
+            <a:schemeClr val="accent1"/>
+          </a:effectRef>
+          <a:fontRef idx="minor">
+            <a:schemeClr val="lt1"/>
+          </a:fontRef>
+        </p:style>
+        <p:txBody>
+          <a:bodyPr rtlCol="0" anchor="ctr" lIns="0" tIns="0" rIns="0" bIns="0"/>
+          <a:lstStyle/>
+          <a:p>
+            <a:pPr algn="ctr">
+              <a:defRPr sz="850" b="1">
+                <a:solidFill>
+                  <a:srgbClr val="0F172A"/>
+                </a:solidFill>
+              </a:defRPr>
+            </a:pPr>
+            <a:r>
+              <a:t>CLINICAL MISSION</a:t>
+            </a:r>
+          </a:p>
+        </p:txBody>
+      </p:sp>
+      <p:sp>
+        <p:nvSpPr>
+          <p:cNvPr id="12" name="Rounded Rectangle 11"/>
+          <p:cNvSpPr/>
+          <p:nvPr/>
+        </p:nvSpPr>
+        <p:spPr>
+          <a:xfrm>
+            <a:off x="8046720" y="1645920"/>
+            <a:ext cx="3429000" cy="4663440"/>
+          </a:xfrm>
+          <a:prstGeom prst="roundRect">
+            <a:avLst/>
+          </a:prstGeom>
+          <a:solidFill>
+            <a:srgbClr val="FFFFFF"/>
+          </a:solidFill>
+          <a:ln w="19050">
+            <a:solidFill>
+              <a:srgbClr val="059669"/>
+            </a:solidFill>
+          </a:ln>
+        </p:spPr>
+        <p:style>
+          <a:lnRef idx="1">
+            <a:schemeClr val="accent1"/>
+          </a:lnRef>
+          <a:fillRef idx="3">
+            <a:schemeClr val="accent1"/>
+          </a:fillRef>
+          <a:effectRef idx="2">
+            <a:schemeClr val="accent1"/>
+          </a:effectRef>
+          <a:fontRef idx="minor">
+            <a:schemeClr val="lt1"/>
+          </a:fontRef>
+        </p:style>
+        <p:txBody>
+          <a:bodyPr rtlCol="0" anchor="ctr"/>
+          <a:lstStyle/>
+          <a:p>
+            <a:pPr algn="ctr"/>
+          </a:p>
+        </p:txBody>
+      </p:sp>
+      <p:sp>
+        <p:nvSpPr>
+          <p:cNvPr id="13" name="TextBox 12"/>
+          <p:cNvSpPr txBox="1"/>
+          <p:nvPr/>
+        </p:nvSpPr>
+        <p:spPr>
+          <a:xfrm>
+            <a:off x="8193024" y="1792224"/>
+            <a:ext cx="3136392" cy="4370832"/>
+          </a:xfrm>
+          <a:prstGeom prst="rect">
+            <a:avLst/>
+          </a:prstGeom>
+          <a:noFill/>
+        </p:spPr>
+        <p:txBody>
+          <a:bodyPr wrap="square" lIns="0" tIns="0" rIns="0" bIns="0">
+            <a:spAutoFit/>
+          </a:bodyPr>
+          <a:lstStyle/>
+          <a:p>
+            <a:pPr>
+              <a:spcAft>
+                <a:spcPts val="800"/>
+              </a:spcAft>
+              <a:defRPr sz="1300" b="1">
+                <a:solidFill>
+                  <a:srgbClr val="059669"/>
+                </a:solidFill>
+              </a:defRPr>
+            </a:pPr>
+            <a:r>
+              <a:t>3. Our Proposed Solution</a:t>
+            </a:r>
+          </a:p>
+          <a:p>
+            <a:pPr>
+              <a:spcAft>
+                <a:spcPts val="600"/>
+              </a:spcAft>
+            </a:pPr>
+            <a:r>
+              <a:rPr b="1" sz="1050">
+                <a:solidFill>
+                  <a:srgbClr val="0F172A"/>
+                </a:solidFill>
+              </a:rPr>
+              <a:t>•  SafeAdapt Framework: </a:t>
+            </a:r>
+            <a:r>
+              <a:rPr sz="1050">
+                <a:solidFill>
+                  <a:srgbClr val="1E293B"/>
+                </a:solidFill>
+              </a:rPr>
+              <a:t>A real-time, fail-closed Test-Time Adaptation architecture that safely adapts models during live WSI streaming.</a:t>
+            </a:r>
+          </a:p>
+          <a:p>
+            <a:pPr>
+              <a:spcAft>
+                <a:spcPts val="600"/>
+              </a:spcAft>
+            </a:pPr>
+            <a:r>
+              <a:rPr b="1" sz="1050">
+                <a:solidFill>
+                  <a:srgbClr val="0F172A"/>
+                </a:solidFill>
+              </a:rPr>
+              <a:t>•  Sinkhorn Optimal Transport: </a:t>
+            </a:r>
+            <a:r>
+              <a:rPr sz="1050">
+                <a:solidFill>
+                  <a:srgbClr val="1E293B"/>
+                </a:solidFill>
+              </a:rPr>
+              <a:t>Enforces balanced marginal transport, making single-class representation collapse mathematically impossible.</a:t>
+            </a:r>
+          </a:p>
+          <a:p>
+            <a:pPr>
+              <a:spcAft>
+                <a:spcPts val="600"/>
+              </a:spcAft>
+            </a:pPr>
+            <a:r>
+              <a:rPr b="1" sz="1050">
+                <a:solidFill>
+                  <a:srgbClr val="0F172A"/>
+                </a:solidFill>
+              </a:rPr>
+              <a:t>•  Conformal Risk Rollback: </a:t>
+            </a:r>
+            <a:r>
+              <a:rPr sz="1050">
+                <a:solidFill>
+                  <a:srgbClr val="1E293B"/>
+                </a:solidFill>
+              </a:rPr>
+              <a:t>Finite-sample statistical bounds guarantee bounded error with an instantaneous 1.8 ms state recovery.</a:t>
+            </a:r>
+          </a:p>
+        </p:txBody>
+      </p:sp>
+      <p:sp>
+        <p:nvSpPr>
+          <p:cNvPr id="14" name="Rounded Rectangle 13"/>
+          <p:cNvSpPr/>
+          <p:nvPr/>
+        </p:nvSpPr>
+        <p:spPr>
+          <a:xfrm>
+            <a:off x="9829800" y="1755648"/>
+            <a:ext cx="1508760" cy="256032"/>
+          </a:xfrm>
+          <a:prstGeom prst="roundRect">
+            <a:avLst/>
+          </a:prstGeom>
+          <a:solidFill>
+            <a:srgbClr val="ECFDF5"/>
+          </a:solidFill>
+          <a:ln w="12700">
+            <a:solidFill>
+              <a:srgbClr val="059669"/>
+            </a:solidFill>
+          </a:ln>
+        </p:spPr>
+        <p:style>
+          <a:lnRef idx="1">
+            <a:schemeClr val="accent1"/>
+          </a:lnRef>
+          <a:fillRef idx="3">
+            <a:schemeClr val="accent1"/>
+          </a:fillRef>
+          <a:effectRef idx="2">
+            <a:schemeClr val="accent1"/>
+          </a:effectRef>
+          <a:fontRef idx="minor">
+            <a:schemeClr val="lt1"/>
+          </a:fontRef>
+        </p:style>
+        <p:txBody>
+          <a:bodyPr rtlCol="0" anchor="ctr" lIns="0" tIns="0" rIns="0" bIns="0"/>
+          <a:lstStyle/>
+          <a:p>
+            <a:pPr algn="ctr">
+              <a:defRPr sz="850" b="1">
+                <a:solidFill>
+                  <a:srgbClr val="059669"/>
+                </a:solidFill>
+              </a:defRPr>
+            </a:pPr>
+            <a:r>
+              <a:t>THE SOLUTION</a:t>
             </a:r>
           </a:p>
         </p:txBody>
@@ -16698,7 +17191,7 @@
               </a:defRPr>
             </a:pPr>
             <a:r>
-              <a:t>PRIOR ART BREAKDOWN</a:t>
+              <a:t>LITERATURE POSITIONING</a:t>
             </a:r>
           </a:p>
         </p:txBody>
@@ -16733,7 +17226,7 @@
               </a:defRPr>
             </a:pPr>
             <a:r>
-              <a:t>Why Standard Test-Time Adaptation Collapses in Pathology</a:t>
+              <a:t>Relevant Prior Art, Critical Research Gaps &amp; Our Key Innovations</a:t>
             </a:r>
           </a:p>
         </p:txBody>
@@ -16787,7 +17280,7 @@
               </a:defRPr>
             </a:pPr>
             <a:r>
-              <a:t>KEY TAKEAWAY:  Entropy minimization creates an unsupervised feedback loop that pulls models into degenerate single-class attractors.</a:t>
+              <a:t>KEY TAKEAWAY:  Existing TTA methods fail because they minimize entropy on corrupted data; SafeAdapt preserves geometry and bounds risk.</a:t>
             </a:r>
           </a:p>
         </p:txBody>
@@ -16801,7 +17294,213 @@
         <p:spPr>
           <a:xfrm>
             <a:off x="731520" y="1645920"/>
-            <a:ext cx="5303520" cy="2194560"/>
+            <a:ext cx="3429000" cy="4663440"/>
+          </a:xfrm>
+          <a:prstGeom prst="roundRect">
+            <a:avLst/>
+          </a:prstGeom>
+          <a:solidFill>
+            <a:srgbClr val="FFFFFF"/>
+          </a:solidFill>
+          <a:ln w="19050">
+            <a:solidFill>
+              <a:srgbClr val="0F172A"/>
+            </a:solidFill>
+          </a:ln>
+        </p:spPr>
+        <p:style>
+          <a:lnRef idx="1">
+            <a:schemeClr val="accent1"/>
+          </a:lnRef>
+          <a:fillRef idx="3">
+            <a:schemeClr val="accent1"/>
+          </a:fillRef>
+          <a:effectRef idx="2">
+            <a:schemeClr val="accent1"/>
+          </a:effectRef>
+          <a:fontRef idx="minor">
+            <a:schemeClr val="lt1"/>
+          </a:fontRef>
+        </p:style>
+        <p:txBody>
+          <a:bodyPr rtlCol="0" anchor="ctr"/>
+          <a:lstStyle/>
+          <a:p>
+            <a:pPr algn="ctr"/>
+          </a:p>
+        </p:txBody>
+      </p:sp>
+      <p:sp>
+        <p:nvSpPr>
+          <p:cNvPr id="7" name="TextBox 6"/>
+          <p:cNvSpPr txBox="1"/>
+          <p:nvPr/>
+        </p:nvSpPr>
+        <p:spPr>
+          <a:xfrm>
+            <a:off x="877824" y="1792224"/>
+            <a:ext cx="3136392" cy="4370832"/>
+          </a:xfrm>
+          <a:prstGeom prst="rect">
+            <a:avLst/>
+          </a:prstGeom>
+          <a:noFill/>
+        </p:spPr>
+        <p:txBody>
+          <a:bodyPr wrap="square" lIns="0" tIns="0" rIns="0" bIns="0">
+            <a:spAutoFit/>
+          </a:bodyPr>
+          <a:lstStyle/>
+          <a:p>
+            <a:pPr>
+              <a:spcAft>
+                <a:spcPts val="800"/>
+              </a:spcAft>
+              <a:defRPr sz="1300" b="1">
+                <a:solidFill>
+                  <a:srgbClr val="0F172A"/>
+                </a:solidFill>
+              </a:defRPr>
+            </a:pPr>
+            <a:r>
+              <a:t>1. Relevant Research (Prior Art)</a:t>
+            </a:r>
+          </a:p>
+          <a:p>
+            <a:pPr>
+              <a:spcAft>
+                <a:spcPts val="600"/>
+              </a:spcAft>
+            </a:pPr>
+            <a:r>
+              <a:rPr b="1" sz="1050">
+                <a:solidFill>
+                  <a:srgbClr val="0F172A"/>
+                </a:solidFill>
+              </a:rPr>
+              <a:t>•  Classical Vision TTA: </a:t>
+            </a:r>
+            <a:r>
+              <a:rPr sz="1050">
+                <a:solidFill>
+                  <a:srgbClr val="1E293B"/>
+                </a:solidFill>
+              </a:rPr>
+              <a:t>Tent (ICLR '21: Shannon entropy minimization on BN layers), EATA (ICML '22: Fisher regularized), SAR (ICLR '23: sharpness-aware minimization).</a:t>
+            </a:r>
+          </a:p>
+          <a:p>
+            <a:pPr>
+              <a:spcAft>
+                <a:spcPts val="600"/>
+              </a:spcAft>
+            </a:pPr>
+            <a:r>
+              <a:rPr b="1" sz="1050">
+                <a:solidFill>
+                  <a:srgbClr val="0F172A"/>
+                </a:solidFill>
+              </a:rPr>
+              <a:t>•  Continual Adaptation: </a:t>
+            </a:r>
+            <a:r>
+              <a:rPr sz="1050">
+                <a:solidFill>
+                  <a:srgbClr val="1E293B"/>
+                </a:solidFill>
+              </a:rPr>
+              <a:t>CoTTA (CVPR '22: mean-teacher with stochastic restoration), RoTTA (CVPR '23: category-balanced memory banks).</a:t>
+            </a:r>
+          </a:p>
+          <a:p>
+            <a:pPr>
+              <a:spcAft>
+                <a:spcPts val="600"/>
+              </a:spcAft>
+            </a:pPr>
+            <a:r>
+              <a:rPr b="1" sz="1050">
+                <a:solidFill>
+                  <a:srgbClr val="0F172A"/>
+                </a:solidFill>
+              </a:rPr>
+              <a:t>•  Test-Time Augmentation: </a:t>
+            </a:r>
+            <a:r>
+              <a:rPr sz="1050">
+                <a:solidFill>
+                  <a:srgbClr val="1E293B"/>
+                </a:solidFill>
+              </a:rPr>
+              <a:t>MEMO (NeurIPS '22: marginal entropy across 16 augmented views).</a:t>
+            </a:r>
+          </a:p>
+        </p:txBody>
+      </p:sp>
+      <p:sp>
+        <p:nvSpPr>
+          <p:cNvPr id="8" name="Rounded Rectangle 7"/>
+          <p:cNvSpPr/>
+          <p:nvPr/>
+        </p:nvSpPr>
+        <p:spPr>
+          <a:xfrm>
+            <a:off x="2514600" y="1755648"/>
+            <a:ext cx="1508760" cy="256032"/>
+          </a:xfrm>
+          <a:prstGeom prst="roundRect">
+            <a:avLst/>
+          </a:prstGeom>
+          <a:solidFill>
+            <a:srgbClr val="ECFDF5"/>
+          </a:solidFill>
+          <a:ln w="12700">
+            <a:solidFill>
+              <a:srgbClr val="0F172A"/>
+            </a:solidFill>
+          </a:ln>
+        </p:spPr>
+        <p:style>
+          <a:lnRef idx="1">
+            <a:schemeClr val="accent1"/>
+          </a:lnRef>
+          <a:fillRef idx="3">
+            <a:schemeClr val="accent1"/>
+          </a:fillRef>
+          <a:effectRef idx="2">
+            <a:schemeClr val="accent1"/>
+          </a:effectRef>
+          <a:fontRef idx="minor">
+            <a:schemeClr val="lt1"/>
+          </a:fontRef>
+        </p:style>
+        <p:txBody>
+          <a:bodyPr rtlCol="0" anchor="ctr" lIns="0" tIns="0" rIns="0" bIns="0"/>
+          <a:lstStyle/>
+          <a:p>
+            <a:pPr algn="ctr">
+              <a:defRPr sz="850" b="1">
+                <a:solidFill>
+                  <a:srgbClr val="0F172A"/>
+                </a:solidFill>
+              </a:defRPr>
+            </a:pPr>
+            <a:r>
+              <a:t>PRIOR ART</a:t>
+            </a:r>
+          </a:p>
+        </p:txBody>
+      </p:sp>
+      <p:sp>
+        <p:nvSpPr>
+          <p:cNvPr id="9" name="Rounded Rectangle 8"/>
+          <p:cNvSpPr/>
+          <p:nvPr/>
+        </p:nvSpPr>
+        <p:spPr>
+          <a:xfrm>
+            <a:off x="4389120" y="1645920"/>
+            <a:ext cx="3429000" cy="4663440"/>
           </a:xfrm>
           <a:prstGeom prst="roundRect">
             <a:avLst/>
@@ -16839,14 +17538,14 @@
       </p:sp>
       <p:sp>
         <p:nvSpPr>
-          <p:cNvPr id="7" name="TextBox 6"/>
+          <p:cNvPr id="10" name="TextBox 9"/>
           <p:cNvSpPr txBox="1"/>
           <p:nvPr/>
         </p:nvSpPr>
         <p:spPr>
           <a:xfrm>
-            <a:off x="877824" y="1792224"/>
-            <a:ext cx="5010912" cy="1901952"/>
+            <a:off x="4535424" y="1792224"/>
+            <a:ext cx="3136392" cy="4370832"/>
           </a:xfrm>
           <a:prstGeom prst="rect">
             <a:avLst/>
@@ -16870,7 +17569,7 @@
               </a:defRPr>
             </a:pPr>
             <a:r>
-              <a:t>The Entropy Minimization Trap (Tent / EATA)</a:t>
+              <a:t>2. Critical Gaps in Prior Art</a:t>
             </a:r>
           </a:p>
           <a:p>
@@ -16885,7 +17584,7 @@
                   <a:srgbClr val="0F172A"/>
                 </a:solidFill>
               </a:rPr>
-              <a:t>•  Core Assumption: </a:t>
+              <a:t>•  Flawed Core Premise: </a:t>
             </a:r>
             <a:r>
               <a:rPr sz="1050">
@@ -16893,7 +17592,7 @@
                   <a:srgbClr val="1E293B"/>
                 </a:solidFill>
               </a:rPr>
-              <a:t>Minimizing prediction entropy H(p) assumes that confident predictions are predominantly correct.</a:t>
+              <a:t>All existing methods assume low entropy = correct predictions. In digital pathology, this triggers catastrophic collapse on 40% of slides.</a:t>
             </a:r>
           </a:p>
           <a:p>
@@ -16908,7 +17607,7 @@
                   <a:srgbClr val="0F172A"/>
                 </a:solidFill>
               </a:rPr>
-              <a:t>•  Histopathology Reality: </a:t>
+              <a:t>•  Scalar Gating Blindness: </a:t>
             </a:r>
             <a:r>
               <a:rPr sz="1050">
@@ -16916,7 +17615,7 @@
                   <a:srgbClr val="1E293B"/>
                 </a:solidFill>
               </a:rPr>
-              <a:t>Severe stain drift causes false predictions to have moderate entropy; minimizing entropy actively reinforces false class assignments.</a:t>
+              <a:t>Fisher weighting (EATA) and gradient-spike checks (SAR) fail because stain drift produces smooth, low-norm gradients that silently drift into collapse.</a:t>
             </a:r>
           </a:p>
           <a:p>
@@ -16931,7 +17630,7 @@
                   <a:srgbClr val="0F172A"/>
                 </a:solidFill>
               </a:rPr>
-              <a:t>•  Feedback Loop: </a:t>
+              <a:t>•  HIPAA &amp; Regulatory Breaches: </a:t>
             </a:r>
             <a:r>
               <a:rPr sz="1050">
@@ -16939,20 +17638,20 @@
                   <a:srgbClr val="1E293B"/>
                 </a:solidFill>
               </a:rPr>
-              <a:t>Corrupted normalization parameters bias the next batch, leading to runaway confirmation bias.</a:t>
-            </a:r>
-          </a:p>
-        </p:txBody>
-      </p:sp>
-      <p:sp>
-        <p:nvSpPr>
-          <p:cNvPr id="8" name="Rounded Rectangle 7"/>
+              <a:t>Continual memory banks (CoTTA, RoTTA) allow Patient A's tissue to pollute Patient B's diagnosis, violating medical privacy.</a:t>
+            </a:r>
+          </a:p>
+        </p:txBody>
+      </p:sp>
+      <p:sp>
+        <p:nvSpPr>
+          <p:cNvPr id="11" name="Rounded Rectangle 10"/>
           <p:cNvSpPr/>
           <p:nvPr/>
         </p:nvSpPr>
         <p:spPr>
           <a:xfrm>
-            <a:off x="4389120" y="1755648"/>
+            <a:off x="6172200" y="1755648"/>
             <a:ext cx="1508760" cy="256032"/>
           </a:xfrm>
           <a:prstGeom prst="roundRect">
@@ -16993,21 +17692,21 @@
               </a:defRPr>
             </a:pPr>
             <a:r>
-              <a:t>FLAWED PREMISE</a:t>
-            </a:r>
-          </a:p>
-        </p:txBody>
-      </p:sp>
-      <p:sp>
-        <p:nvSpPr>
-          <p:cNvPr id="9" name="Rounded Rectangle 8"/>
+              <a:t>IDENTIFIED GAPS</a:t>
+            </a:r>
+          </a:p>
+        </p:txBody>
+      </p:sp>
+      <p:sp>
+        <p:nvSpPr>
+          <p:cNvPr id="12" name="Rounded Rectangle 11"/>
           <p:cNvSpPr/>
           <p:nvPr/>
         </p:nvSpPr>
         <p:spPr>
           <a:xfrm>
-            <a:off x="731520" y="4023360"/>
-            <a:ext cx="5303520" cy="2286000"/>
+            <a:off x="8046720" y="1645920"/>
+            <a:ext cx="3429000" cy="4663440"/>
           </a:xfrm>
           <a:prstGeom prst="roundRect">
             <a:avLst/>
@@ -17017,7 +17716,7 @@
           </a:solidFill>
           <a:ln w="19050">
             <a:solidFill>
-              <a:srgbClr val="DC2626"/>
+              <a:srgbClr val="059669"/>
             </a:solidFill>
           </a:ln>
         </p:spPr>
@@ -17045,14 +17744,14 @@
       </p:sp>
       <p:sp>
         <p:nvSpPr>
-          <p:cNvPr id="10" name="TextBox 9"/>
+          <p:cNvPr id="13" name="TextBox 12"/>
           <p:cNvSpPr txBox="1"/>
           <p:nvPr/>
         </p:nvSpPr>
         <p:spPr>
           <a:xfrm>
-            <a:off x="877824" y="4169664"/>
-            <a:ext cx="5010912" cy="1993392"/>
+            <a:off x="8193024" y="1792224"/>
+            <a:ext cx="3136392" cy="4370832"/>
           </a:xfrm>
           <a:prstGeom prst="rect">
             <a:avLst/>
@@ -17071,12 +17770,12 @@
               </a:spcAft>
               <a:defRPr sz="1300" b="1">
                 <a:solidFill>
-                  <a:srgbClr val="DC2626"/>
+                  <a:srgbClr val="059669"/>
                 </a:solidFill>
               </a:defRPr>
             </a:pPr>
             <a:r>
-              <a:t>Catastrophic Attractor State Collapse</a:t>
+              <a:t>3. What We Are Doing Differently</a:t>
             </a:r>
           </a:p>
           <a:p>
@@ -17091,7 +17790,7 @@
                   <a:srgbClr val="0F172A"/>
                 </a:solidFill>
               </a:rPr>
-              <a:t>•  Single-Class Attractor: </a:t>
+              <a:t>•  Exact Marginal Transport: </a:t>
             </a:r>
             <a:r>
               <a:rPr sz="1050">
@@ -17099,7 +17798,7 @@
                   <a:srgbClr val="1E293B"/>
                 </a:solidFill>
               </a:rPr>
-              <a:t>Batch Normalization running statistics drift until all features collapse into a single degenerate cluster.</a:t>
+              <a:t>Replaces entropy minimization with Sinkhorn Optimal Transport to preserve category geometry without label feedback.</a:t>
             </a:r>
           </a:p>
           <a:p>
@@ -17114,7 +17813,7 @@
                   <a:srgbClr val="0F172A"/>
                 </a:solidFill>
               </a:rPr>
-              <a:t>•  Clinical Consequence: </a:t>
+              <a:t>•  Explicit OOD Slack Channel: </a:t>
             </a:r>
             <a:r>
               <a:rPr sz="1050">
@@ -17122,7 +17821,7 @@
                   <a:srgbClr val="1E293B"/>
                 </a:solidFill>
               </a:rPr>
-              <a:t>The network predicts 100% of tissue patches as normal, driving cancer detection F1-score from 0.85 down to 0.05.</a:t>
+              <a:t>Routes non-neoplastic tissue artifacts (surgical ink, air bubbles) into a slack channel to protect diagnostic prototypes.</a:t>
             </a:r>
           </a:p>
           <a:p>
@@ -17137,7 +17836,7 @@
                   <a:srgbClr val="0F172A"/>
                 </a:solidFill>
               </a:rPr>
-              <a:t>•  40% Collapse Rate: </a:t>
+              <a:t>•  Provable Finite-Sample Safety: </a:t>
             </a:r>
             <a:r>
               <a:rPr sz="1050">
@@ -17145,31 +17844,31 @@
                   <a:srgbClr val="1E293B"/>
                 </a:solidFill>
               </a:rPr>
-              <a:t>On CAMELYON17 Center 4, standard Tent collapses on 40% of patient slides (e.g., Slide 29 drops to 0.51 AUROC).</a:t>
-            </a:r>
-          </a:p>
-        </p:txBody>
-      </p:sp>
-      <p:sp>
-        <p:nvSpPr>
-          <p:cNvPr id="11" name="Rounded Rectangle 10"/>
+              <a:t>Establishes Theorem 1 conformal bounds with sub-2ms GPU rollback and deterministic episodic per-slide resets.</a:t>
+            </a:r>
+          </a:p>
+        </p:txBody>
+      </p:sp>
+      <p:sp>
+        <p:nvSpPr>
+          <p:cNvPr id="14" name="Rounded Rectangle 13"/>
           <p:cNvSpPr/>
           <p:nvPr/>
         </p:nvSpPr>
         <p:spPr>
           <a:xfrm>
-            <a:off x="4389120" y="4133088"/>
+            <a:off x="9829800" y="1755648"/>
             <a:ext cx="1508760" cy="256032"/>
           </a:xfrm>
           <a:prstGeom prst="roundRect">
             <a:avLst/>
           </a:prstGeom>
           <a:solidFill>
-            <a:srgbClr val="FEF2F2"/>
+            <a:srgbClr val="ECFDF5"/>
           </a:solidFill>
           <a:ln w="12700">
             <a:solidFill>
-              <a:srgbClr val="DC2626"/>
+              <a:srgbClr val="059669"/>
             </a:solidFill>
           </a:ln>
         </p:spPr>
@@ -17194,116 +17893,12 @@
             <a:pPr algn="ctr">
               <a:defRPr sz="850" b="1">
                 <a:solidFill>
-                  <a:srgbClr val="DC2626"/>
+                  <a:srgbClr val="059669"/>
                 </a:solidFill>
               </a:defRPr>
             </a:pPr>
             <a:r>
-              <a:t>40% COLLAPSE</a:t>
-            </a:r>
-          </a:p>
-        </p:txBody>
-      </p:sp>
-      <p:sp>
-        <p:nvSpPr>
-          <p:cNvPr id="12" name="Rounded Rectangle 11"/>
-          <p:cNvSpPr/>
-          <p:nvPr/>
-        </p:nvSpPr>
-        <p:spPr>
-          <a:xfrm>
-            <a:off x="6254496" y="2150246"/>
-            <a:ext cx="5230368" cy="3929106"/>
-          </a:xfrm>
-          <a:prstGeom prst="roundRect">
-            <a:avLst/>
-          </a:prstGeom>
-          <a:solidFill>
-            <a:srgbClr val="FFFFFF"/>
-          </a:solidFill>
-          <a:ln w="12700">
-            <a:solidFill>
-              <a:srgbClr val="E2E8F0"/>
-            </a:solidFill>
-          </a:ln>
-        </p:spPr>
-        <p:style>
-          <a:lnRef idx="1">
-            <a:schemeClr val="accent1"/>
-          </a:lnRef>
-          <a:fillRef idx="3">
-            <a:schemeClr val="accent1"/>
-          </a:fillRef>
-          <a:effectRef idx="2">
-            <a:schemeClr val="accent1"/>
-          </a:effectRef>
-          <a:fontRef idx="minor">
-            <a:schemeClr val="lt1"/>
-          </a:fontRef>
-        </p:style>
-        <p:txBody>
-          <a:bodyPr rtlCol="0" anchor="ctr"/>
-          <a:lstStyle/>
-          <a:p>
-            <a:pPr algn="ctr"/>
-          </a:p>
-        </p:txBody>
-      </p:sp>
-      <p:pic>
-        <p:nvPicPr>
-          <p:cNvPr id="13" name="Picture 12" descr="fig_tent_collapse_mechanism.png"/>
-          <p:cNvPicPr>
-            <a:picLocks noChangeAspect="1"/>
-          </p:cNvPicPr>
-          <p:nvPr/>
-        </p:nvPicPr>
-        <p:blipFill>
-          <a:blip r:embed="rId2"/>
-          <a:stretch>
-            <a:fillRect/>
-          </a:stretch>
-        </p:blipFill>
-        <p:spPr>
-          <a:xfrm>
-            <a:off x="6309360" y="2205110"/>
-            <a:ext cx="5120640" cy="3545058"/>
-          </a:xfrm>
-          <a:prstGeom prst="rect">
-            <a:avLst/>
-          </a:prstGeom>
-        </p:spPr>
-      </p:pic>
-      <p:sp>
-        <p:nvSpPr>
-          <p:cNvPr id="14" name="TextBox 13"/>
-          <p:cNvSpPr txBox="1"/>
-          <p:nvPr/>
-        </p:nvSpPr>
-        <p:spPr>
-          <a:xfrm>
-            <a:off x="6309360" y="5795889"/>
-            <a:ext cx="5120640" cy="228600"/>
-          </a:xfrm>
-          <a:prstGeom prst="rect">
-            <a:avLst/>
-          </a:prstGeom>
-          <a:noFill/>
-        </p:spPr>
-        <p:txBody>
-          <a:bodyPr wrap="square" lIns="0" tIns="0" rIns="0" bIns="0">
-            <a:spAutoFit/>
-          </a:bodyPr>
-          <a:lstStyle/>
-          <a:p>
-            <a:pPr algn="ctr">
-              <a:defRPr sz="850" i="1">
-                <a:solidFill>
-                  <a:srgbClr val="64748B"/>
-                </a:solidFill>
-              </a:defRPr>
-            </a:pPr>
-            <a:r>
-              <a:t>Empirical Collapse: Tent entropy optimization destroys latent feature margins across streaming WSI batches.</a:t>
+              <a:t>OUR INNOVATIONS</a:t>
             </a:r>
           </a:p>
         </p:txBody>
@@ -17594,7 +18189,7 @@
                   <a:srgbClr val="1E293B"/>
                 </a:solidFill>
               </a:rPr>
-              <a:t>Consider parameter uncertainty delta_theta ~ N(0, Sigma_theta) around adapted weights.</a:t>
+              <a:t>Consider parameter uncertainty Δθ ~ 𝒩(0, Σ_θ) around adapted normalization weights.</a:t>
             </a:r>
           </a:p>
           <a:p>
@@ -17617,7 +18212,7 @@
                   <a:srgbClr val="1E293B"/>
                 </a:solidFill>
               </a:rPr>
-              <a:t>Var[p(y|x)] = grad_theta p(y|x)^T Sigma_theta grad_theta p(y|x) + O(||Sigma||^2).</a:t>
+              <a:t>Var[p(y|x)] = ∇_θ p(y|x)ᵀ Σ_θ ∇_θ p(y|x) + 𝒪(‖Σ_θ‖²).</a:t>
             </a:r>
           </a:p>
           <a:p>
@@ -17640,7 +18235,7 @@
                   <a:srgbClr val="1E293B"/>
                 </a:solidFill>
               </a:rPr>
-              <a:t>As softmax probability p -&gt; 1 or p -&gt; 0, the derivative grad_theta p vanishes quadratically: grad p = p(1 - p) grad z.</a:t>
+              <a:t>As softmax probability p → 1 or p → 0, the derivative ∇_θ p vanishes quadratically: ∇_θ p = p(1 − p) ∇_θ z.</a:t>
             </a:r>
           </a:p>
           <a:p>
@@ -17663,7 +18258,7 @@
                   <a:srgbClr val="1E293B"/>
                 </a:solidFill>
               </a:rPr>
-              <a:t>Predictive entropy approaches zero exactly when epistemic weight variance reaches its global peak!</a:t>
+              <a:t>Predictive entropy approaches zero (ℋ(p) → 0) exactly when epistemic weight variance reaches its global peak!</a:t>
             </a:r>
           </a:p>
         </p:txBody>
@@ -17800,7 +18395,7 @@
               </a:defRPr>
             </a:pPr>
             <a:r>
-              <a:t>2. Rank Inversion: rho = -0.9917</a:t>
+              <a:t>2. Rank Inversion: ρ = −0.9917</a:t>
             </a:r>
           </a:p>
           <a:p>
@@ -18248,7 +18843,7 @@
               </a:defRPr>
             </a:pPr>
             <a:r>
-              <a:t>PROPOSED FRAMEWORK</a:t>
+              <a:t>WORKFLOW &amp; EXECUTION PIPELINE</a:t>
             </a:r>
           </a:p>
         </p:txBody>
@@ -18283,7 +18878,7 @@
               </a:defRPr>
             </a:pPr>
             <a:r>
-              <a:t>SafeAdapt: A Deterministic, Fail-Closed TTA Architecture</a:t>
+              <a:t>End-to-End Workflow Pipeline &amp; System Architecture</a:t>
             </a:r>
           </a:p>
         </p:txBody>
@@ -18337,7 +18932,7 @@
               </a:defRPr>
             </a:pPr>
             <a:r>
-              <a:t>KEY TAKEAWAY:  SafeAdapt introduces geometry-preserving optimal transport, contextual artifact rejection, and finite-sample risk bounds.</a:t>
+              <a:t>KEY TAKEAWAY:  Four interlocking safeguards execute in a single forward-backward pass per patch batch, with deterministic state reset per slide.</a:t>
             </a:r>
           </a:p>
         </p:txBody>
@@ -18495,7 +19090,7 @@
               </a:defRPr>
             </a:pPr>
             <a:r>
-              <a:t>1. Dual-Stream Anchor</a:t>
+              <a:t>Step 1: Dual-Stream Anchor</a:t>
             </a:r>
           </a:p>
           <a:p>
@@ -18510,7 +19105,7 @@
               </a:defRPr>
             </a:pPr>
             <a:r>
-              <a:t>Maintains frozen source anchor theta_0 in parallel with adaptive student theta_t to preserve diagnostic geometry.</a:t>
+              <a:t>Streams patches through frozen anchor θ_0 in parallel with adaptive student θ_t to preserve diagnostic geometry.</a:t>
             </a:r>
           </a:p>
         </p:txBody>
@@ -18564,7 +19159,7 @@
               </a:defRPr>
             </a:pPr>
             <a:r>
-              <a:t>2. Sinkhorn Optimal Transport</a:t>
+              <a:t>Step 2: Sinkhorn Optimal Transport</a:t>
             </a:r>
           </a:p>
           <a:p>
@@ -18633,7 +19228,7 @@
               </a:defRPr>
             </a:pPr>
             <a:r>
-              <a:t>3. Memory Routing (CMR)</a:t>
+              <a:t>Step 3: Memory Routing (CMR)</a:t>
             </a:r>
           </a:p>
           <a:p>
@@ -18702,7 +19297,7 @@
               </a:defRPr>
             </a:pPr>
             <a:r>
-              <a:t>4. Conformal Risk Rollback</a:t>
+              <a:t>Step 4: Conformal Risk Rollback</a:t>
             </a:r>
           </a:p>
           <a:p>
@@ -18717,7 +19312,7 @@
               </a:defRPr>
             </a:pPr>
             <a:r>
-              <a:t>Finite-sample risk monitor halts adaptation and restores theta_0 in 1.8 ms if parameter drift exceeds alpha.</a:t>
+              <a:t>Finite-sample risk monitor halts adaptation and restores θ_0 in 1.8 ms if parameter drift exceeds α = 0.05.</a:t>
             </a:r>
           </a:p>
         </p:txBody>
@@ -19008,7 +19603,7 @@
                   <a:srgbClr val="1E293B"/>
                 </a:solidFill>
               </a:rPr>
-              <a:t>Measures the geometric distance between streaming batch features Z in R^(B x d) and anchor prototype dictionary C in R^(K x d).</a:t>
+              <a:t>Measures the geometric distance between streaming batch features Z ∈ ℝ^(B×d) and anchor prototype dictionary C ∈ ℝ^(K×d).</a:t>
             </a:r>
           </a:p>
           <a:p>
@@ -19031,7 +19626,7 @@
                   <a:srgbClr val="1E293B"/>
                 </a:solidFill>
               </a:rPr>
-              <a:t>min_{P in U(B, K)} &lt;P, M&gt; - epsilon H(P), where cost matrix M_ik = ||z_i - c_k||_2^2.</a:t>
+              <a:t>min_{P ∈ 𝒰(B, K)} ⟨P, M⟩ − ε ℋ(P), where cost matrix M_ik = ‖z_i − c_k‖₂².</a:t>
             </a:r>
           </a:p>
           <a:p>
@@ -19054,7 +19649,7 @@
                   <a:srgbClr val="1E293B"/>
                 </a:solidFill>
               </a:rPr>
-              <a:t>Row constraint P 1_K = (1/B) 1_B ensures every patch is mapped; column constraint P^T 1_B = (1/K) 1_K enforces balanced class capacity.</a:t>
+              <a:t>Row constraint P 1_K = (1/B) 1_B ensures every patch is mapped; column constraint Pᵀ 1_B = (1/K) 1_K enforces balanced class capacity.</a:t>
             </a:r>
           </a:p>
         </p:txBody>
@@ -19214,7 +19809,7 @@
                   <a:srgbClr val="1E293B"/>
                 </a:solidFill>
               </a:rPr>
-              <a:t>Solved via alternating matrix scaling: P* = diag(u) exp(-M / epsilon) diag(v).</a:t>
+              <a:t>Solved via alternating matrix scaling: P* = diag(u) exp(−M / ε) diag(v).</a:t>
             </a:r>
           </a:p>
           <a:p>
@@ -19811,7 +20406,7 @@
                   <a:srgbClr val="1E293B"/>
                 </a:solidFill>
               </a:rPr>
-              <a:t>Maintains high-confidence source representations in a compact key-value memory bank M_mem = (K_mem, V_mem).</a:t>
+              <a:t>Maintains high-confidence source representations in a compact key-value memory bank ℳ_mem = (K_mem, V_mem).</a:t>
             </a:r>
           </a:p>
           <a:p>
@@ -19834,7 +20429,7 @@
                   <a:srgbClr val="1E293B"/>
                 </a:solidFill>
               </a:rPr>
-              <a:t>Attention weights A = Softmax(Q K_mem^T / sqrt(d)) compute contextual similarity between streaming patches and trusted source knowledge.</a:t>
+              <a:t>Attention weights A = Softmax(Q K_memᵀ / √d) compute contextual similarity between streaming patches and trusted source knowledge.</a:t>
             </a:r>
           </a:p>
           <a:p>
@@ -20614,7 +21209,7 @@
                   <a:srgbClr val="1E293B"/>
                 </a:solidFill>
               </a:rPr>
-              <a:t>Evaluates non-conformity s_i = 1 - f_theta(x_i)_y on streaming calibration batches.</a:t>
+              <a:t>Evaluates non-conformity s_i = 1 − f_θ(x_i)_y on streaming calibration batches.</a:t>
             </a:r>
           </a:p>
           <a:p>
@@ -20637,7 +21232,7 @@
                   <a:srgbClr val="1E293B"/>
                 </a:solidFill>
               </a:rPr>
-              <a:t>P( R(theta_t) &lt;= alpha ) &gt;= 1 - delta, where empirical risk R is bounded with high probability.</a:t>
+              <a:t>ℙ( ℛ(θ_t) ≤ α ) ≥ 1 − δ, where empirical risk ℛ is bounded with high probability.</a:t>
             </a:r>
           </a:p>
           <a:p>
@@ -20866,7 +21461,7 @@
                   <a:srgbClr val="1E293B"/>
                 </a:solidFill>
               </a:rPr>
-              <a:t>If empirical risk breaches threshold alpha = 0.05, the adaptation controller trips an emergency interlock.</a:t>
+              <a:t>If empirical risk breaches threshold α = 0.05, the adaptation controller trips an emergency interlock.</a:t>
             </a:r>
           </a:p>
           <a:p>
@@ -21049,7 +21644,7 @@
                   <a:srgbClr val="1E293B"/>
                 </a:solidFill>
               </a:rPr>
-              <a:t>Maintains an atomic FIFO cache of pristine anchor parameters theta_0 in GPU VRAM.</a:t>
+              <a:t>Maintains an atomic FIFO cache of pristine anchor parameters θ_0 in GPU VRAM.</a:t>
             </a:r>
           </a:p>
           <a:p>
@@ -21072,7 +21667,7 @@
                   <a:srgbClr val="1E293B"/>
                 </a:solidFill>
               </a:rPr>
-              <a:t>Upon interlock trigger, restores theta_0 in exactly 1.8 ms—completely sub-frame and non-blocking.</a:t>
+              <a:t>Upon interlock trigger, restores θ_0 in exactly 1.8 ms—completely sub-frame and non-blocking.</a:t>
             </a:r>
           </a:p>
           <a:p>

</xml_diff>